<commit_message>
results-deck: stronger comparators on slide 8
Swap MDAgents / MAC Framework / RareAgents out of the literature
comparison; swap in AMIE (Tu 2024, OSCE diagnostic AI), MedAgents
(Tang 2024, ACL — multi-agent CoT on 9 benchmarks), and AgentClinic
(Schmidgall 2024 — simulated patient encounters).

Numbers are citable from each paper's published text:
  AMIE        — beat PCPs on 28/32 specialist axes; 149 cases
  MedAgents   — 86.7% avg with GPT-4 (MedQA 83.7%, PubMedQA 94.3%)
  AgentClinic — Claude-3.5 62.1% on AgentClinic-MedQA; PCPs 54% ±28.5

Keep ZODIAC + ClinicalLab as the closest real-case comparators with
qualitative phrasing. Two new bib entries (Tu2024AMIE,
Schmidgall2024AgentClinic); Tang2024MedAgents was already in bib.

Co-Authored-By: Claude Opus 4.7 (1M context) <noreply@anthropic.com>
</commit_message>
<xml_diff>
--- a/docs/results_presentation/CMADS_Results_Presentation.pptx
+++ b/docs/results_presentation/CMADS_Results_Presentation.pptx
@@ -7635,7 +7635,7 @@
                             <a:srgbClr val="34495E"/>
                           </a:solidFill>
                         </a:rPr>
-                        <a:t>MDAgents (Kim 2024)</a:t>
+                        <a:t>AMIE (Tu 2024)</a:t>
                       </a:r>
                     </a:p>
                   </a:txBody>
@@ -7657,7 +7657,7 @@
                             <a:srgbClr val="34495E"/>
                           </a:solidFill>
                         </a:rPr>
-                        <a:t>10 MCQ benchmarks</a:t>
+                        <a:t>149 OSCE scenarios · 20 PCPs</a:t>
                       </a:r>
                     </a:p>
                   </a:txBody>
@@ -7679,7 +7679,7 @@
                             <a:srgbClr val="34495E"/>
                           </a:solidFill>
                         </a:rPr>
-                        <a:t>(qualitative) Best on 7/10</a:t>
+                        <a:t>Beat PCPs on 28/32 specialist axes; 24/26 patient-actor axes</a:t>
                       </a:r>
                     </a:p>
                   </a:txBody>
@@ -7723,7 +7723,231 @@
                             <a:srgbClr val="34495E"/>
                           </a:solidFill>
                         </a:rPr>
+                        <a:t>◐</a:t>
+                      </a:r>
+                    </a:p>
+                  </a:txBody>
+                  <a:tcPr>
+                    <a:solidFill>
+                      <a:srgbClr val="FFFFFF"/>
+                    </a:solidFill>
+                  </a:tcPr>
+                </a:tc>
+              </a:tr>
+              <a:tr h="701040">
+                <a:tc>
+                  <a:txBody>
+                    <a:bodyPr/>
+                    <a:lstStyle/>
+                    <a:p>
+                      <a:pPr algn="l"/>
+                      <a:r>
+                        <a:rPr sz="1100" b="1">
+                          <a:solidFill>
+                            <a:srgbClr val="34495E"/>
+                          </a:solidFill>
+                        </a:rPr>
+                        <a:t>MedAgents (Tang 2024)</a:t>
+                      </a:r>
+                    </a:p>
+                  </a:txBody>
+                  <a:tcPr>
+                    <a:solidFill>
+                      <a:srgbClr val="F7F9FC"/>
+                    </a:solidFill>
+                  </a:tcPr>
+                </a:tc>
+                <a:tc>
+                  <a:txBody>
+                    <a:bodyPr/>
+                    <a:lstStyle/>
+                    <a:p>
+                      <a:pPr algn="ctr"/>
+                      <a:r>
+                        <a:rPr sz="1100" b="0">
+                          <a:solidFill>
+                            <a:srgbClr val="34495E"/>
+                          </a:solidFill>
+                        </a:rPr>
+                        <a:t>9 medical-reasoning benchmarks</a:t>
+                      </a:r>
+                    </a:p>
+                  </a:txBody>
+                  <a:tcPr>
+                    <a:solidFill>
+                      <a:srgbClr val="F7F9FC"/>
+                    </a:solidFill>
+                  </a:tcPr>
+                </a:tc>
+                <a:tc>
+                  <a:txBody>
+                    <a:bodyPr/>
+                    <a:lstStyle/>
+                    <a:p>
+                      <a:pPr algn="ctr"/>
+                      <a:r>
+                        <a:rPr sz="1100" b="0">
+                          <a:solidFill>
+                            <a:srgbClr val="34495E"/>
+                          </a:solidFill>
+                        </a:rPr>
+                        <a:t>86.7% avg with GPT-4 (MedQA 83.7%, PubMedQA 94.3%)</a:t>
+                      </a:r>
+                    </a:p>
+                  </a:txBody>
+                  <a:tcPr>
+                    <a:solidFill>
+                      <a:srgbClr val="F7F9FC"/>
+                    </a:solidFill>
+                  </a:tcPr>
+                </a:tc>
+                <a:tc>
+                  <a:txBody>
+                    <a:bodyPr/>
+                    <a:lstStyle/>
+                    <a:p>
+                      <a:pPr algn="ctr"/>
+                      <a:r>
+                        <a:rPr sz="1100" b="0">
+                          <a:solidFill>
+                            <a:srgbClr val="34495E"/>
+                          </a:solidFill>
+                        </a:rPr>
+                        <a:t>49% DIRECT  ·  95% Found  (n=100, 8 disease families)</a:t>
+                      </a:r>
+                    </a:p>
+                  </a:txBody>
+                  <a:tcPr>
+                    <a:solidFill>
+                      <a:srgbClr val="F7F9FC"/>
+                    </a:solidFill>
+                  </a:tcPr>
+                </a:tc>
+                <a:tc>
+                  <a:txBody>
+                    <a:bodyPr/>
+                    <a:lstStyle/>
+                    <a:p>
+                      <a:pPr algn="ctr"/>
+                      <a:r>
+                        <a:rPr sz="1100" b="0">
+                          <a:solidFill>
+                            <a:srgbClr val="34495E"/>
+                          </a:solidFill>
+                        </a:rPr>
                         <a:t>✗</a:t>
+                      </a:r>
+                    </a:p>
+                  </a:txBody>
+                  <a:tcPr>
+                    <a:solidFill>
+                      <a:srgbClr val="F7F9FC"/>
+                    </a:solidFill>
+                  </a:tcPr>
+                </a:tc>
+              </a:tr>
+              <a:tr h="701040">
+                <a:tc>
+                  <a:txBody>
+                    <a:bodyPr/>
+                    <a:lstStyle/>
+                    <a:p>
+                      <a:pPr algn="l"/>
+                      <a:r>
+                        <a:rPr sz="1100" b="1">
+                          <a:solidFill>
+                            <a:srgbClr val="34495E"/>
+                          </a:solidFill>
+                        </a:rPr>
+                        <a:t>AgentClinic (Schmidgall 2024)</a:t>
+                      </a:r>
+                    </a:p>
+                  </a:txBody>
+                  <a:tcPr>
+                    <a:solidFill>
+                      <a:srgbClr val="FFFFFF"/>
+                    </a:solidFill>
+                  </a:tcPr>
+                </a:tc>
+                <a:tc>
+                  <a:txBody>
+                    <a:bodyPr/>
+                    <a:lstStyle/>
+                    <a:p>
+                      <a:pPr algn="ctr"/>
+                      <a:r>
+                        <a:rPr sz="1100" b="0">
+                          <a:solidFill>
+                            <a:srgbClr val="34495E"/>
+                          </a:solidFill>
+                        </a:rPr>
+                        <a:t>215 USMLE + 260 specialist + 749 multilingual</a:t>
+                      </a:r>
+                    </a:p>
+                  </a:txBody>
+                  <a:tcPr>
+                    <a:solidFill>
+                      <a:srgbClr val="FFFFFF"/>
+                    </a:solidFill>
+                  </a:tcPr>
+                </a:tc>
+                <a:tc>
+                  <a:txBody>
+                    <a:bodyPr/>
+                    <a:lstStyle/>
+                    <a:p>
+                      <a:pPr algn="ctr"/>
+                      <a:r>
+                        <a:rPr sz="1100" b="0">
+                          <a:solidFill>
+                            <a:srgbClr val="34495E"/>
+                          </a:solidFill>
+                        </a:rPr>
+                        <a:t>Claude-3.5: 62.1% on AgentClinic-MedQA; PCPs 54% ±28.5</a:t>
+                      </a:r>
+                    </a:p>
+                  </a:txBody>
+                  <a:tcPr>
+                    <a:solidFill>
+                      <a:srgbClr val="FFFFFF"/>
+                    </a:solidFill>
+                  </a:tcPr>
+                </a:tc>
+                <a:tc>
+                  <a:txBody>
+                    <a:bodyPr/>
+                    <a:lstStyle/>
+                    <a:p>
+                      <a:pPr algn="ctr"/>
+                      <a:r>
+                        <a:rPr sz="1100" b="0">
+                          <a:solidFill>
+                            <a:srgbClr val="34495E"/>
+                          </a:solidFill>
+                        </a:rPr>
+                        <a:t>49% DIRECT  ·  95% Found  (n=100, 8 disease families)</a:t>
+                      </a:r>
+                    </a:p>
+                  </a:txBody>
+                  <a:tcPr>
+                    <a:solidFill>
+                      <a:srgbClr val="FFFFFF"/>
+                    </a:solidFill>
+                  </a:tcPr>
+                </a:tc>
+                <a:tc>
+                  <a:txBody>
+                    <a:bodyPr/>
+                    <a:lstStyle/>
+                    <a:p>
+                      <a:pPr algn="ctr"/>
+                      <a:r>
+                        <a:rPr sz="1100" b="0">
+                          <a:solidFill>
+                            <a:srgbClr val="34495E"/>
+                          </a:solidFill>
+                        </a:rPr>
+                        <a:t>◐</a:t>
                       </a:r>
                     </a:p>
                   </a:txBody>
@@ -7958,230 +8182,6 @@
                   </a:tcPr>
                 </a:tc>
               </a:tr>
-              <a:tr h="701040">
-                <a:tc>
-                  <a:txBody>
-                    <a:bodyPr/>
-                    <a:lstStyle/>
-                    <a:p>
-                      <a:pPr algn="l"/>
-                      <a:r>
-                        <a:rPr sz="1100" b="1">
-                          <a:solidFill>
-                            <a:srgbClr val="34495E"/>
-                          </a:solidFill>
-                        </a:rPr>
-                        <a:t>MAC Framework (2025)</a:t>
-                      </a:r>
-                    </a:p>
-                  </a:txBody>
-                  <a:tcPr>
-                    <a:solidFill>
-                      <a:srgbClr val="F7F9FC"/>
-                    </a:solidFill>
-                  </a:tcPr>
-                </a:tc>
-                <a:tc>
-                  <a:txBody>
-                    <a:bodyPr/>
-                    <a:lstStyle/>
-                    <a:p>
-                      <a:pPr algn="ctr"/>
-                      <a:r>
-                        <a:rPr sz="1100" b="0">
-                          <a:solidFill>
-                            <a:srgbClr val="34495E"/>
-                          </a:solidFill>
-                        </a:rPr>
-                        <a:t>302 rare-disease cases</a:t>
-                      </a:r>
-                    </a:p>
-                  </a:txBody>
-                  <a:tcPr>
-                    <a:solidFill>
-                      <a:srgbClr val="F7F9FC"/>
-                    </a:solidFill>
-                  </a:tcPr>
-                </a:tc>
-                <a:tc>
-                  <a:txBody>
-                    <a:bodyPr/>
-                    <a:lstStyle/>
-                    <a:p>
-                      <a:pPr algn="ctr"/>
-                      <a:r>
-                        <a:rPr sz="1100" b="0">
-                          <a:solidFill>
-                            <a:srgbClr val="34495E"/>
-                          </a:solidFill>
-                        </a:rPr>
-                        <a:t>(qualitative) Outperforms self-consistency</a:t>
-                      </a:r>
-                    </a:p>
-                  </a:txBody>
-                  <a:tcPr>
-                    <a:solidFill>
-                      <a:srgbClr val="F7F9FC"/>
-                    </a:solidFill>
-                  </a:tcPr>
-                </a:tc>
-                <a:tc>
-                  <a:txBody>
-                    <a:bodyPr/>
-                    <a:lstStyle/>
-                    <a:p>
-                      <a:pPr algn="ctr"/>
-                      <a:r>
-                        <a:rPr sz="1100" b="0">
-                          <a:solidFill>
-                            <a:srgbClr val="34495E"/>
-                          </a:solidFill>
-                        </a:rPr>
-                        <a:t>Common chronic disease cohort</a:t>
-                      </a:r>
-                    </a:p>
-                  </a:txBody>
-                  <a:tcPr>
-                    <a:solidFill>
-                      <a:srgbClr val="F7F9FC"/>
-                    </a:solidFill>
-                  </a:tcPr>
-                </a:tc>
-                <a:tc>
-                  <a:txBody>
-                    <a:bodyPr/>
-                    <a:lstStyle/>
-                    <a:p>
-                      <a:pPr algn="ctr"/>
-                      <a:r>
-                        <a:rPr sz="1100" b="0">
-                          <a:solidFill>
-                            <a:srgbClr val="34495E"/>
-                          </a:solidFill>
-                        </a:rPr>
-                        <a:t>✗</a:t>
-                      </a:r>
-                    </a:p>
-                  </a:txBody>
-                  <a:tcPr>
-                    <a:solidFill>
-                      <a:srgbClr val="F7F9FC"/>
-                    </a:solidFill>
-                  </a:tcPr>
-                </a:tc>
-              </a:tr>
-              <a:tr h="701040">
-                <a:tc>
-                  <a:txBody>
-                    <a:bodyPr/>
-                    <a:lstStyle/>
-                    <a:p>
-                      <a:pPr algn="l"/>
-                      <a:r>
-                        <a:rPr sz="1100" b="1">
-                          <a:solidFill>
-                            <a:srgbClr val="34495E"/>
-                          </a:solidFill>
-                        </a:rPr>
-                        <a:t>RareAgents (Chen 2024)</a:t>
-                      </a:r>
-                    </a:p>
-                  </a:txBody>
-                  <a:tcPr>
-                    <a:solidFill>
-                      <a:srgbClr val="FFFFFF"/>
-                    </a:solidFill>
-                  </a:tcPr>
-                </a:tc>
-                <a:tc>
-                  <a:txBody>
-                    <a:bodyPr/>
-                    <a:lstStyle/>
-                    <a:p>
-                      <a:pPr algn="ctr"/>
-                      <a:r>
-                        <a:rPr sz="1100" b="0">
-                          <a:solidFill>
-                            <a:srgbClr val="34495E"/>
-                          </a:solidFill>
-                        </a:rPr>
-                        <a:t>RareBench + MIMIC-Ext-Rare</a:t>
-                      </a:r>
-                    </a:p>
-                  </a:txBody>
-                  <a:tcPr>
-                    <a:solidFill>
-                      <a:srgbClr val="FFFFFF"/>
-                    </a:solidFill>
-                  </a:tcPr>
-                </a:tc>
-                <a:tc>
-                  <a:txBody>
-                    <a:bodyPr/>
-                    <a:lstStyle/>
-                    <a:p>
-                      <a:pPr algn="ctr"/>
-                      <a:r>
-                        <a:rPr sz="1100" b="0">
-                          <a:solidFill>
-                            <a:srgbClr val="34495E"/>
-                          </a:solidFill>
-                        </a:rPr>
-                        <a:t>(qualitative) Open backbone beats GPT-4o</a:t>
-                      </a:r>
-                    </a:p>
-                  </a:txBody>
-                  <a:tcPr>
-                    <a:solidFill>
-                      <a:srgbClr val="FFFFFF"/>
-                    </a:solidFill>
-                  </a:tcPr>
-                </a:tc>
-                <a:tc>
-                  <a:txBody>
-                    <a:bodyPr/>
-                    <a:lstStyle/>
-                    <a:p>
-                      <a:pPr algn="ctr"/>
-                      <a:r>
-                        <a:rPr sz="1100" b="0">
-                          <a:solidFill>
-                            <a:srgbClr val="34495E"/>
-                          </a:solidFill>
-                        </a:rPr>
-                        <a:t>DIRECT/INDIRECT/MISS, not Hit@K</a:t>
-                      </a:r>
-                    </a:p>
-                  </a:txBody>
-                  <a:tcPr>
-                    <a:solidFill>
-                      <a:srgbClr val="FFFFFF"/>
-                    </a:solidFill>
-                  </a:tcPr>
-                </a:tc>
-                <a:tc>
-                  <a:txBody>
-                    <a:bodyPr/>
-                    <a:lstStyle/>
-                    <a:p>
-                      <a:pPr algn="ctr"/>
-                      <a:r>
-                        <a:rPr sz="1100" b="0">
-                          <a:solidFill>
-                            <a:srgbClr val="34495E"/>
-                          </a:solidFill>
-                        </a:rPr>
-                        <a:t>✗</a:t>
-                      </a:r>
-                    </a:p>
-                  </a:txBody>
-                  <a:tcPr>
-                    <a:solidFill>
-                      <a:srgbClr val="FFFFFF"/>
-                    </a:solidFill>
-                  </a:tcPr>
-                </a:tc>
-              </a:tr>
             </a:tbl>
           </a:graphicData>
         </a:graphic>
@@ -8215,7 +8215,7 @@
                   <a:srgbClr val="7F8C8D"/>
                 </a:solidFill>
               </a:rPr>
-              <a:t>Apples-to-apples is rare in this literature: most evaluate on MCQ benchmarks or a single specialty, not end-to-end EHR records across 8 families. Numbers marked (qualitative) are the strongest claim verifiable from the bib entry / abstract.</a:t>
+              <a:t>Bold-style numbers are citable from the paper's abstract or experiments section. AMIE and AgentClinic share the closest evaluation shape (real-case differential diagnosis with a clinician baseline). MedAgents reports MCQ accuracy, included as a different-metric reference. (qualitative) marks the strongest non-numeric claim.</a:t>
             </a:r>
           </a:p>
         </p:txBody>

</xml_diff>

<commit_message>
results-deck: slide 2 bullets now overview the whole system
Replace pipeline-mechanics bullets (parallel Stage 1, adaptive loop,
non-destructive review) with system-level aspects so slide 2 covers
the breadth, not the depth, of the work:

  1. Synthetic patient generation (Synthea + medallion data pipeline)
  2. 7-agent LangGraph pipeline (one-line summary)
  3. Vector database (Qdrant) for RAG over past cases + NICE
  4. 4-tier memory subsystem
  5. Open-source LLMs (GPT-OSS-120B + Qwen3-32B judge via Groq)
  6. Doctor-facing console

Co-Authored-By: Claude Opus 4.7 (1M context) <noreply@anthropic.com>
</commit_message>
<xml_diff>
--- a/docs/results_presentation/CMADS_Results_Presentation.pptx
+++ b/docs/results_presentation/CMADS_Results_Presentation.pptx
@@ -3560,7 +3560,7 @@
                   <a:srgbClr val="142B4A"/>
                 </a:solidFill>
               </a:rPr>
-              <a:t>7 agents on LangGraph</a:t>
+              <a:t>Synthetic patient generation</a:t>
             </a:r>
           </a:p>
         </p:txBody>
@@ -3594,7 +3594,7 @@
                   <a:srgbClr val="34495E"/>
                 </a:solidFill>
               </a:rPr>
-              <a:t>Coordinated by a typed shared state — not custom orchestration.</a:t>
+              <a:t>Synthea → Bronze → Silver → Gold medallion pipeline; one cohort, no PHI.</a:t>
             </a:r>
           </a:p>
         </p:txBody>
@@ -3671,7 +3671,7 @@
                   <a:srgbClr val="142B4A"/>
                 </a:solidFill>
               </a:rPr>
-              <a:t>Stage 1 parallel</a:t>
+              <a:t>7-agent LangGraph pipeline</a:t>
             </a:r>
           </a:p>
         </p:txBody>
@@ -3705,7 +3705,7 @@
                   <a:srgbClr val="34495E"/>
                 </a:solidFill>
               </a:rPr>
-              <a:t>EHR Analyst + Lab Interpreter fan out from START.</a:t>
+              <a:t>EHR + Labs → diagnosis → review → refine → evaluate → NICE treatment.</a:t>
             </a:r>
           </a:p>
         </p:txBody>
@@ -3782,7 +3782,7 @@
                   <a:srgbClr val="142B4A"/>
                 </a:solidFill>
               </a:rPr>
-              <a:t>Adaptive diagnostic loop</a:t>
+              <a:t>Vector database (Qdrant)</a:t>
             </a:r>
           </a:p>
         </p:txBody>
@@ -3816,7 +3816,7 @@
                   <a:srgbClr val="34495E"/>
                 </a:solidFill>
               </a:rPr>
-              <a:t>Up to 3 rounds with a confidence threshold.</a:t>
+              <a:t>BioLORD-2023 embeddings of past cases + NICE guidelines; RAG at recall time.</a:t>
             </a:r>
           </a:p>
         </p:txBody>
@@ -3893,7 +3893,7 @@
                   <a:srgbClr val="142B4A"/>
                 </a:solidFill>
               </a:rPr>
-              <a:t>Non-destructive review</a:t>
+              <a:t>4-tier memory subsystem</a:t>
             </a:r>
           </a:p>
         </p:txBody>
@@ -3927,7 +3927,7 @@
                   <a:srgbClr val="34495E"/>
                 </a:solidFill>
               </a:rPr>
-              <a:t>Reviewer challenges; Refiner can change the primary diagnosis but the original output stays in the trace.</a:t>
+              <a:t>Working · Episodic · Semantic · Case-based — written every patient.</a:t>
             </a:r>
           </a:p>
         </p:txBody>
@@ -4004,7 +4004,7 @@
                   <a:srgbClr val="142B4A"/>
                 </a:solidFill>
               </a:rPr>
-              <a:t>Gated treatment planning</a:t>
+              <a:t>Open-source LLMs</a:t>
             </a:r>
           </a:p>
         </p:txBody>
@@ -4038,7 +4038,7 @@
                   <a:srgbClr val="34495E"/>
                 </a:solidFill>
               </a:rPr>
-              <a:t>NICE guidelines via Qdrant — runs on DIRECT matches only.</a:t>
+              <a:t>GPT-OSS-120B reasoning + Qwen3-32B judge via Groq — reproducible under $30/1k.</a:t>
             </a:r>
           </a:p>
         </p:txBody>
@@ -4115,7 +4115,7 @@
                   <a:srgbClr val="142B4A"/>
                 </a:solidFill>
               </a:rPr>
-              <a:t>4-tier memory subsystem</a:t>
+              <a:t>Doctor-facing console</a:t>
             </a:r>
           </a:p>
         </p:txBody>
@@ -4149,7 +4149,7 @@
                   <a:srgbClr val="34495E"/>
                 </a:solidFill>
               </a:rPr>
-              <a:t>Working · Episodic · Semantic · Case-based (BioLORD-2023 embeddings).</a:t>
+              <a:t>Agent inspector, similar-case browser, treatment-safety review, persisted verdicts.</a:t>
             </a:r>
           </a:p>
         </p:txBody>

</xml_diff>

<commit_message>
results-deck: relabel cards (drop 'memory ON / memory OFF' phrasing)
</commit_message>
<xml_diff>
--- a/docs/results_presentation/CMADS_Results_Presentation.pptx
+++ b/docs/results_presentation/CMADS_Results_Presentation.pptx
@@ -4331,7 +4331,7 @@
                   <a:srgbClr val="ECF0F1"/>
                 </a:solidFill>
               </a:rPr>
-              <a:t>Memory ON (n=100, batch_3 + batch_4) vs memory OFF (n=160, mas_results/)</a:t>
+              <a:t>Baseline pipeline (n=160) vs four-tier memory subsystem (n=100, batch_3 + batch_4)</a:t>
             </a:r>
           </a:p>
         </p:txBody>
@@ -4444,7 +4444,7 @@
                   <a:srgbClr val="7F8C8D"/>
                 </a:solidFill>
               </a:rPr>
-              <a:t>Memory OFF · 160 patients</a:t>
+              <a:t>Original pipeline · 160 patients</a:t>
             </a:r>
           </a:p>
         </p:txBody>
@@ -4829,7 +4829,7 @@
                   <a:srgbClr val="7F8C8D"/>
                 </a:solidFill>
               </a:rPr>
-              <a:t>Memory ON · 100 patients</a:t>
+              <a:t>4-tier subsystem · 100 patients</a:t>
             </a:r>
           </a:p>
         </p:txBody>

</xml_diff>

<commit_message>
results-deck: prewire 160 vs 160 (extra60 cohort placeholder)
compute_metrics now emits cohorts.extra60 + cohorts.combined_160 when
data/gold/mas_results_improved_extra60/ has ≥60 evaluations; falls back
to combined_100 otherwise. Slide 3 reads whichever multi-level cohort
is larger and auto-recomputes the Δ strip + interpretation line, so a
single build after the run lands flips the deck to 160 vs 160.

Custom batch file: data/gold/batches/batch_extra60_for_160_vs_160.json
(50 patients from batch_5 + 10 from batch_1, all uncovered by the
prior multi-level cohort).

Run is in progress (pid 88089, MAS_RESULTS_DIR=mas_results_improved_extra60,
MEMORY_ENABLED=true). Watcher at /tmp/cmads_extra60_watch.sh will auto-
rebuild + commit when the 60th evaluation lands.

Co-Authored-By: Claude Opus 4.7 (1M context) <noreply@anthropic.com>
</commit_message>
<xml_diff>
--- a/docs/results_presentation/CMADS_Results_Presentation.pptx
+++ b/docs/results_presentation/CMADS_Results_Presentation.pptx
@@ -4331,7 +4331,7 @@
                   <a:srgbClr val="ECF0F1"/>
                 </a:solidFill>
               </a:rPr>
-              <a:t>Baseline pipeline (n=160) vs four-tier memory subsystem (n=100, batch_3 + batch_4)</a:t>
+              <a:t>Baseline pipeline (n=160) vs four-tier memory subsystem (n=100)</a:t>
             </a:r>
           </a:p>
         </p:txBody>
@@ -4829,7 +4829,7 @@
                   <a:srgbClr val="7F8C8D"/>
                 </a:solidFill>
               </a:rPr>
-              <a:t>4-tier subsystem · 100 patients</a:t>
+              <a:t>4-tier subsystem · 100 patients (batch_3 + batch_4)</a:t>
             </a:r>
           </a:p>
         </p:txBody>
@@ -5508,7 +5508,7 @@
                   <a:srgbClr val="7F8C8D"/>
                 </a:solidFill>
               </a:rPr>
-              <a:t>Memory broadens recall (Found +7.5 pp, MISS −6.7 pp) but shifts confirmed matches into the related-but-not-exact bucket (DIRECT −24.1 pp). Different patient subsets per arm — comparison is descriptive, not a paired test.</a:t>
+              <a:t>Memory broadens recall (Found +7.5 pp, MISS -7.5 pp) but shifts confirmed matches into the related-but-not-exact bucket (DIRECT -24.1 pp). Different patient subsets per arm — comparison is descriptive, not a paired test.</a:t>
             </a:r>
           </a:p>
         </p:txBody>

</xml_diff>

<commit_message>
results-deck: 160 vs 160 (extra60 cohort complete)
</commit_message>
<xml_diff>
--- a/docs/results_presentation/CMADS_Results_Presentation.pptx
+++ b/docs/results_presentation/CMADS_Results_Presentation.pptx
@@ -4331,7 +4331,7 @@
                   <a:srgbClr val="ECF0F1"/>
                 </a:solidFill>
               </a:rPr>
-              <a:t>Baseline pipeline (n=160) vs four-tier memory subsystem (n=100)</a:t>
+              <a:t>Baseline pipeline (n=160) vs four-tier memory subsystem (n=160)</a:t>
             </a:r>
           </a:p>
         </p:txBody>
@@ -4829,7 +4829,7 @@
                   <a:srgbClr val="7F8C8D"/>
                 </a:solidFill>
               </a:rPr>
-              <a:t>4-tier subsystem · 100 patients (batch_3 + batch_4)</a:t>
+              <a:t>4-tier subsystem · 160 patients</a:t>
             </a:r>
           </a:p>
         </p:txBody>
@@ -4897,7 +4897,7 @@
                   <a:srgbClr val="D35400"/>
                 </a:solidFill>
               </a:rPr>
-              <a:t>49.0%   (49/100)</a:t>
+              <a:t>52.5%   (84/160)</a:t>
             </a:r>
           </a:p>
         </p:txBody>
@@ -4965,7 +4965,7 @@
                   <a:srgbClr val="D35400"/>
                 </a:solidFill>
               </a:rPr>
-              <a:t>95.0%   (95/100)</a:t>
+              <a:t>93.8%   (150/160)</a:t>
             </a:r>
           </a:p>
         </p:txBody>
@@ -5033,7 +5033,7 @@
                   <a:srgbClr val="D35400"/>
                 </a:solidFill>
               </a:rPr>
-              <a:t>5.0%   (5/100)</a:t>
+              <a:t>6.2%   (10/160)</a:t>
             </a:r>
           </a:p>
         </p:txBody>
@@ -5101,7 +5101,7 @@
                   <a:srgbClr val="D35400"/>
                 </a:solidFill>
               </a:rPr>
-              <a:t>65.3%   (62/95)</a:t>
+              <a:t>61.3%   (92/150)</a:t>
             </a:r>
           </a:p>
         </p:txBody>
@@ -5248,7 +5248,7 @@
                   <a:srgbClr val="C0392B"/>
                 </a:solidFill>
               </a:rPr>
-              <a:t>-24.1 pp</a:t>
+              <a:t>-20.6 pp</a:t>
             </a:r>
           </a:p>
         </p:txBody>
@@ -5361,7 +5361,7 @@
                   <a:srgbClr val="27AE60"/>
                 </a:solidFill>
               </a:rPr>
-              <a:t>+7.5 pp</a:t>
+              <a:t>+6.3 pp</a:t>
             </a:r>
           </a:p>
         </p:txBody>
@@ -5474,7 +5474,7 @@
                   <a:srgbClr val="27AE60"/>
                 </a:solidFill>
               </a:rPr>
-              <a:t>-7.5 pp</a:t>
+              <a:t>-6.3 pp</a:t>
             </a:r>
           </a:p>
         </p:txBody>
@@ -5508,7 +5508,7 @@
                   <a:srgbClr val="7F8C8D"/>
                 </a:solidFill>
               </a:rPr>
-              <a:t>Memory broadens recall (Found +7.5 pp, MISS -7.5 pp) but shifts confirmed matches into the related-but-not-exact bucket (DIRECT -24.1 pp). Different patient subsets per arm — comparison is descriptive, not a paired test.</a:t>
+              <a:t>Memory broadens recall (Found +6.3 pp, MISS -6.3 pp) but shifts confirmed matches into the related-but-not-exact bucket (DIRECT -20.6 pp). Different patient subsets per arm — comparison is descriptive, not a paired test.</a:t>
             </a:r>
           </a:p>
         </p:txBody>

</xml_diff>

<commit_message>
deck: add slide 4 — single-LLM vs multi-agent controlled (n=160)
  build_pptx.py adds slide_single_llm_vs_multiagent: two cards
  (single-LLM amber vs multi-agent blue), Δ strip, McNemar callout.
  compute_metrics.py emits cohorts.single_llm_baseline (from
  data/gold/mas_results_single_llm_baseline/).

  Numbers shown:
    Single LLM call:    40.0% DIRECT  68.1% Found  31.9% MISS
    7-agent pipeline:   73.1% DIRECT  87.5% Found  12.5% MISS
    Δ (multi-single):   +33.1 pp     +19.4 pp     -19.4 pp
    Paired contingency 48/69/16/27   85 discordant   p < 0.0001

  Slide count 6 -> 7, verifier updated.
</commit_message>
<xml_diff>
--- a/docs/results_presentation/CMADS_Results_Presentation.pptx
+++ b/docs/results_presentation/CMADS_Results_Presentation.pptx
@@ -11,6 +11,7 @@
     <p:sldId id="259" r:id="rId10"/>
     <p:sldId id="260" r:id="rId11"/>
     <p:sldId id="261" r:id="rId12"/>
+    <p:sldId id="262" r:id="rId13"/>
   </p:sldIdLst>
   <p:sldSz cx="12191695" cy="6858000" type="screen4x3"/>
   <p:notesSz cx="6858000" cy="9144000"/>
@@ -5759,7 +5760,7 @@
                   <a:srgbClr val="FFFFFF"/>
                 </a:solidFill>
               </a:rPr>
-              <a:t>Doctor dashboard — features overview</a:t>
+              <a:t>Multi-agent orchestration vs single LLM call</a:t>
             </a:r>
           </a:p>
           <a:p>
@@ -5769,55 +5770,31 @@
                   <a:srgbClr val="ECF0F1"/>
                 </a:solidFill>
               </a:rPr>
-              <a:t>Four features that make the run reviewable</a:t>
-            </a:r>
-          </a:p>
-        </p:txBody>
-      </p:sp>
-      <p:pic>
-        <p:nvPicPr>
-          <p:cNvPr id="5" name="Picture 4" descr="doctor_console.png"/>
-          <p:cNvPicPr>
-            <a:picLocks noChangeAspect="1"/>
-          </p:cNvPicPr>
-          <p:nvPr/>
-        </p:nvPicPr>
-        <p:blipFill>
-          <a:blip r:embed="rId2"/>
-          <a:stretch>
-            <a:fillRect/>
-          </a:stretch>
-        </p:blipFill>
-        <p:spPr>
-          <a:xfrm>
-            <a:off x="365760" y="1097280"/>
-            <a:ext cx="7315200" cy="4572000"/>
-          </a:xfrm>
-          <a:prstGeom prst="rect">
-            <a:avLst/>
-          </a:prstGeom>
-        </p:spPr>
-      </p:pic>
-      <p:sp>
-        <p:nvSpPr>
-          <p:cNvPr id="6" name="Oval 5"/>
+              <a:t>Same 160 UUIDs · same reasoning model (GPT-OSS-120B) · same judge (Qwen3-32B)</a:t>
+            </a:r>
+          </a:p>
+        </p:txBody>
+      </p:sp>
+      <p:sp>
+        <p:nvSpPr>
+          <p:cNvPr id="5" name="Rounded Rectangle 4"/>
           <p:cNvSpPr/>
           <p:nvPr/>
         </p:nvSpPr>
         <p:spPr>
           <a:xfrm>
-            <a:off x="7955279" y="1097280"/>
-            <a:ext cx="411480" cy="411480"/>
-          </a:xfrm>
-          <a:prstGeom prst="ellipse">
+            <a:off x="548640" y="1097280"/>
+            <a:ext cx="5394960" cy="3200400"/>
+          </a:xfrm>
+          <a:prstGeom prst="roundRect">
             <a:avLst/>
           </a:prstGeom>
           <a:solidFill>
-            <a:srgbClr val="D35400"/>
+            <a:srgbClr val="FFFFFF"/>
           </a:solidFill>
           <a:ln w="19050">
             <a:solidFill>
-              <a:srgbClr val="FFFFFF"/>
+              <a:srgbClr val="D35400"/>
             </a:solidFill>
           </a:ln>
         </p:spPr>
@@ -5836,17 +5813,43 @@
           </a:fontRef>
         </p:style>
         <p:txBody>
-          <a:bodyPr rtlCol="0" anchor="ctr" lIns="0" rIns="0" tIns="0" bIns="0"/>
+          <a:bodyPr rtlCol="0" anchor="ctr"/>
           <a:lstStyle/>
           <a:p>
             <a:pPr algn="ctr"/>
-            <a:r>
-              <a:rPr sz="1400" b="1">
-                <a:solidFill>
-                  <a:srgbClr val="FFFFFF"/>
-                </a:solidFill>
-              </a:rPr>
-              <a:t>1</a:t>
+          </a:p>
+        </p:txBody>
+      </p:sp>
+      <p:sp>
+        <p:nvSpPr>
+          <p:cNvPr id="6" name="TextBox 5"/>
+          <p:cNvSpPr txBox="1"/>
+          <p:nvPr/>
+        </p:nvSpPr>
+        <p:spPr>
+          <a:xfrm>
+            <a:off x="777240" y="1234440"/>
+            <a:ext cx="5029200" cy="411480"/>
+          </a:xfrm>
+          <a:prstGeom prst="rect">
+            <a:avLst/>
+          </a:prstGeom>
+          <a:noFill/>
+        </p:spPr>
+        <p:txBody>
+          <a:bodyPr wrap="square" lIns="45720" rIns="45720">
+            <a:spAutoFit/>
+          </a:bodyPr>
+          <a:lstStyle/>
+          <a:p>
+            <a:pPr algn="l"/>
+            <a:r>
+              <a:rPr sz="1800" b="1">
+                <a:solidFill>
+                  <a:srgbClr val="D35400"/>
+                </a:solidFill>
+              </a:rPr>
+              <a:t>Single LLM call</a:t>
             </a:r>
           </a:p>
         </p:txBody>
@@ -5859,28 +5862,28 @@
         </p:nvSpPr>
         <p:spPr>
           <a:xfrm>
-            <a:off x="8458199" y="1051560"/>
-            <a:ext cx="3840480" cy="411480"/>
-          </a:xfrm>
-          <a:prstGeom prst="rect">
-            <a:avLst/>
-          </a:prstGeom>
-          <a:noFill/>
-        </p:spPr>
-        <p:txBody>
-          <a:bodyPr wrap="square" lIns="45720" rIns="45720">
-            <a:spAutoFit/>
-          </a:bodyPr>
-          <a:lstStyle/>
-          <a:p>
-            <a:pPr algn="l"/>
-            <a:r>
-              <a:rPr sz="1200" b="1">
-                <a:solidFill>
-                  <a:srgbClr val="142B4A"/>
-                </a:solidFill>
-              </a:rPr>
-              <a:t>Agent workflow inline</a:t>
+            <a:off x="777240" y="1664208"/>
+            <a:ext cx="5029200" cy="365760"/>
+          </a:xfrm>
+          <a:prstGeom prst="rect">
+            <a:avLst/>
+          </a:prstGeom>
+          <a:noFill/>
+        </p:spPr>
+        <p:txBody>
+          <a:bodyPr wrap="square" lIns="45720" rIns="45720">
+            <a:spAutoFit/>
+          </a:bodyPr>
+          <a:lstStyle/>
+          <a:p>
+            <a:pPr algn="l"/>
+            <a:r>
+              <a:rPr sz="1100" b="0">
+                <a:solidFill>
+                  <a:srgbClr val="7F8C8D"/>
+                </a:solidFill>
+              </a:rPr>
+              <a:t>1 prompt per patient</a:t>
             </a:r>
           </a:p>
         </p:txBody>
@@ -5893,52 +5896,222 @@
         </p:nvSpPr>
         <p:spPr>
           <a:xfrm>
-            <a:off x="8458199" y="1417319"/>
-            <a:ext cx="3840480" cy="777240"/>
-          </a:xfrm>
-          <a:prstGeom prst="rect">
-            <a:avLst/>
-          </a:prstGeom>
-          <a:noFill/>
-        </p:spPr>
-        <p:txBody>
-          <a:bodyPr wrap="square" lIns="45720" rIns="45720">
-            <a:spAutoFit/>
-          </a:bodyPr>
-          <a:lstStyle/>
-          <a:p>
-            <a:pPr algn="l"/>
-            <a:r>
-              <a:rPr sz="1000" b="0">
+            <a:off x="822959" y="2194560"/>
+            <a:ext cx="2468880" cy="457200"/>
+          </a:xfrm>
+          <a:prstGeom prst="rect">
+            <a:avLst/>
+          </a:prstGeom>
+          <a:noFill/>
+        </p:spPr>
+        <p:txBody>
+          <a:bodyPr wrap="square" lIns="45720" rIns="45720">
+            <a:spAutoFit/>
+          </a:bodyPr>
+          <a:lstStyle/>
+          <a:p>
+            <a:pPr algn="l"/>
+            <a:r>
+              <a:rPr sz="1300" b="1">
                 <a:solidFill>
                   <a:srgbClr val="34495E"/>
                 </a:solidFill>
               </a:rPr>
-              <a:t>Every stage's output one click away, rendered as a doctor-readable narrative.</a:t>
-            </a:r>
-          </a:p>
-        </p:txBody>
-      </p:sp>
-      <p:sp>
-        <p:nvSpPr>
-          <p:cNvPr id="9" name="Oval 8"/>
+              <a:t>DIRECT</a:t>
+            </a:r>
+          </a:p>
+        </p:txBody>
+      </p:sp>
+      <p:sp>
+        <p:nvSpPr>
+          <p:cNvPr id="9" name="TextBox 8"/>
+          <p:cNvSpPr txBox="1"/>
+          <p:nvPr/>
+        </p:nvSpPr>
+        <p:spPr>
+          <a:xfrm>
+            <a:off x="3291840" y="2194560"/>
+            <a:ext cx="2560320" cy="457200"/>
+          </a:xfrm>
+          <a:prstGeom prst="rect">
+            <a:avLst/>
+          </a:prstGeom>
+          <a:noFill/>
+        </p:spPr>
+        <p:txBody>
+          <a:bodyPr wrap="square" lIns="45720" rIns="45720">
+            <a:spAutoFit/>
+          </a:bodyPr>
+          <a:lstStyle/>
+          <a:p>
+            <a:pPr algn="l"/>
+            <a:r>
+              <a:rPr sz="1600" b="1">
+                <a:solidFill>
+                  <a:srgbClr val="D35400"/>
+                </a:solidFill>
+              </a:rPr>
+              <a:t>40.0%   (64/160)</a:t>
+            </a:r>
+          </a:p>
+        </p:txBody>
+      </p:sp>
+      <p:sp>
+        <p:nvSpPr>
+          <p:cNvPr id="10" name="TextBox 9"/>
+          <p:cNvSpPr txBox="1"/>
+          <p:nvPr/>
+        </p:nvSpPr>
+        <p:spPr>
+          <a:xfrm>
+            <a:off x="822959" y="2788920"/>
+            <a:ext cx="2468880" cy="457200"/>
+          </a:xfrm>
+          <a:prstGeom prst="rect">
+            <a:avLst/>
+          </a:prstGeom>
+          <a:noFill/>
+        </p:spPr>
+        <p:txBody>
+          <a:bodyPr wrap="square" lIns="45720" rIns="45720">
+            <a:spAutoFit/>
+          </a:bodyPr>
+          <a:lstStyle/>
+          <a:p>
+            <a:pPr algn="l"/>
+            <a:r>
+              <a:rPr sz="1300" b="1">
+                <a:solidFill>
+                  <a:srgbClr val="34495E"/>
+                </a:solidFill>
+              </a:rPr>
+              <a:t>Found (D + I)</a:t>
+            </a:r>
+          </a:p>
+        </p:txBody>
+      </p:sp>
+      <p:sp>
+        <p:nvSpPr>
+          <p:cNvPr id="11" name="TextBox 10"/>
+          <p:cNvSpPr txBox="1"/>
+          <p:nvPr/>
+        </p:nvSpPr>
+        <p:spPr>
+          <a:xfrm>
+            <a:off x="3291840" y="2788920"/>
+            <a:ext cx="2560320" cy="457200"/>
+          </a:xfrm>
+          <a:prstGeom prst="rect">
+            <a:avLst/>
+          </a:prstGeom>
+          <a:noFill/>
+        </p:spPr>
+        <p:txBody>
+          <a:bodyPr wrap="square" lIns="45720" rIns="45720">
+            <a:spAutoFit/>
+          </a:bodyPr>
+          <a:lstStyle/>
+          <a:p>
+            <a:pPr algn="l"/>
+            <a:r>
+              <a:rPr sz="1600" b="1">
+                <a:solidFill>
+                  <a:srgbClr val="D35400"/>
+                </a:solidFill>
+              </a:rPr>
+              <a:t>68.1%   (109/160)</a:t>
+            </a:r>
+          </a:p>
+        </p:txBody>
+      </p:sp>
+      <p:sp>
+        <p:nvSpPr>
+          <p:cNvPr id="12" name="TextBox 11"/>
+          <p:cNvSpPr txBox="1"/>
+          <p:nvPr/>
+        </p:nvSpPr>
+        <p:spPr>
+          <a:xfrm>
+            <a:off x="822959" y="3383280"/>
+            <a:ext cx="2468880" cy="457200"/>
+          </a:xfrm>
+          <a:prstGeom prst="rect">
+            <a:avLst/>
+          </a:prstGeom>
+          <a:noFill/>
+        </p:spPr>
+        <p:txBody>
+          <a:bodyPr wrap="square" lIns="45720" rIns="45720">
+            <a:spAutoFit/>
+          </a:bodyPr>
+          <a:lstStyle/>
+          <a:p>
+            <a:pPr algn="l"/>
+            <a:r>
+              <a:rPr sz="1300" b="1">
+                <a:solidFill>
+                  <a:srgbClr val="34495E"/>
+                </a:solidFill>
+              </a:rPr>
+              <a:t>MISS</a:t>
+            </a:r>
+          </a:p>
+        </p:txBody>
+      </p:sp>
+      <p:sp>
+        <p:nvSpPr>
+          <p:cNvPr id="13" name="TextBox 12"/>
+          <p:cNvSpPr txBox="1"/>
+          <p:nvPr/>
+        </p:nvSpPr>
+        <p:spPr>
+          <a:xfrm>
+            <a:off x="3291840" y="3383280"/>
+            <a:ext cx="2560320" cy="457200"/>
+          </a:xfrm>
+          <a:prstGeom prst="rect">
+            <a:avLst/>
+          </a:prstGeom>
+          <a:noFill/>
+        </p:spPr>
+        <p:txBody>
+          <a:bodyPr wrap="square" lIns="45720" rIns="45720">
+            <a:spAutoFit/>
+          </a:bodyPr>
+          <a:lstStyle/>
+          <a:p>
+            <a:pPr algn="l"/>
+            <a:r>
+              <a:rPr sz="1600" b="1">
+                <a:solidFill>
+                  <a:srgbClr val="D35400"/>
+                </a:solidFill>
+              </a:rPr>
+              <a:t>31.9%   (51/160)</a:t>
+            </a:r>
+          </a:p>
+        </p:txBody>
+      </p:sp>
+      <p:sp>
+        <p:nvSpPr>
+          <p:cNvPr id="14" name="Rounded Rectangle 13"/>
           <p:cNvSpPr/>
           <p:nvPr/>
         </p:nvSpPr>
         <p:spPr>
           <a:xfrm>
-            <a:off x="7955279" y="2240280"/>
-            <a:ext cx="411480" cy="411480"/>
-          </a:xfrm>
-          <a:prstGeom prst="ellipse">
+            <a:off x="6217920" y="1097280"/>
+            <a:ext cx="5394960" cy="3200400"/>
+          </a:xfrm>
+          <a:prstGeom prst="roundRect">
             <a:avLst/>
           </a:prstGeom>
           <a:solidFill>
-            <a:srgbClr val="D35400"/>
+            <a:srgbClr val="FFFFFF"/>
           </a:solidFill>
           <a:ln w="19050">
             <a:solidFill>
-              <a:srgbClr val="FFFFFF"/>
+              <a:srgbClr val="1F4E79"/>
             </a:solidFill>
           </a:ln>
         </p:spPr>
@@ -5957,109 +6130,339 @@
           </a:fontRef>
         </p:style>
         <p:txBody>
-          <a:bodyPr rtlCol="0" anchor="ctr" lIns="0" rIns="0" tIns="0" bIns="0"/>
+          <a:bodyPr rtlCol="0" anchor="ctr"/>
           <a:lstStyle/>
           <a:p>
             <a:pPr algn="ctr"/>
+          </a:p>
+        </p:txBody>
+      </p:sp>
+      <p:sp>
+        <p:nvSpPr>
+          <p:cNvPr id="15" name="TextBox 14"/>
+          <p:cNvSpPr txBox="1"/>
+          <p:nvPr/>
+        </p:nvSpPr>
+        <p:spPr>
+          <a:xfrm>
+            <a:off x="6446520" y="1234440"/>
+            <a:ext cx="5029200" cy="411480"/>
+          </a:xfrm>
+          <a:prstGeom prst="rect">
+            <a:avLst/>
+          </a:prstGeom>
+          <a:noFill/>
+        </p:spPr>
+        <p:txBody>
+          <a:bodyPr wrap="square" lIns="45720" rIns="45720">
+            <a:spAutoFit/>
+          </a:bodyPr>
+          <a:lstStyle/>
+          <a:p>
+            <a:pPr algn="l"/>
+            <a:r>
+              <a:rPr sz="1800" b="1">
+                <a:solidFill>
+                  <a:srgbClr val="1F4E79"/>
+                </a:solidFill>
+              </a:rPr>
+              <a:t>Multi-agent pipeline (7 agents)</a:t>
+            </a:r>
+          </a:p>
+        </p:txBody>
+      </p:sp>
+      <p:sp>
+        <p:nvSpPr>
+          <p:cNvPr id="16" name="TextBox 15"/>
+          <p:cNvSpPr txBox="1"/>
+          <p:nvPr/>
+        </p:nvSpPr>
+        <p:spPr>
+          <a:xfrm>
+            <a:off x="6446520" y="1664208"/>
+            <a:ext cx="5029200" cy="365760"/>
+          </a:xfrm>
+          <a:prstGeom prst="rect">
+            <a:avLst/>
+          </a:prstGeom>
+          <a:noFill/>
+        </p:spPr>
+        <p:txBody>
+          <a:bodyPr wrap="square" lIns="45720" rIns="45720">
+            <a:spAutoFit/>
+          </a:bodyPr>
+          <a:lstStyle/>
+          <a:p>
+            <a:pPr algn="l"/>
+            <a:r>
+              <a:rPr sz="1100" b="0">
+                <a:solidFill>
+                  <a:srgbClr val="7F8C8D"/>
+                </a:solidFill>
+              </a:rPr>
+              <a:t>Parallel Stage 1 + adaptive Diagnostic loop + Reviewer-Refiner</a:t>
+            </a:r>
+          </a:p>
+        </p:txBody>
+      </p:sp>
+      <p:sp>
+        <p:nvSpPr>
+          <p:cNvPr id="17" name="TextBox 16"/>
+          <p:cNvSpPr txBox="1"/>
+          <p:nvPr/>
+        </p:nvSpPr>
+        <p:spPr>
+          <a:xfrm>
+            <a:off x="6492240" y="2194560"/>
+            <a:ext cx="2468880" cy="457200"/>
+          </a:xfrm>
+          <a:prstGeom prst="rect">
+            <a:avLst/>
+          </a:prstGeom>
+          <a:noFill/>
+        </p:spPr>
+        <p:txBody>
+          <a:bodyPr wrap="square" lIns="45720" rIns="45720">
+            <a:spAutoFit/>
+          </a:bodyPr>
+          <a:lstStyle/>
+          <a:p>
+            <a:pPr algn="l"/>
+            <a:r>
+              <a:rPr sz="1300" b="1">
+                <a:solidFill>
+                  <a:srgbClr val="34495E"/>
+                </a:solidFill>
+              </a:rPr>
+              <a:t>DIRECT</a:t>
+            </a:r>
+          </a:p>
+        </p:txBody>
+      </p:sp>
+      <p:sp>
+        <p:nvSpPr>
+          <p:cNvPr id="18" name="TextBox 17"/>
+          <p:cNvSpPr txBox="1"/>
+          <p:nvPr/>
+        </p:nvSpPr>
+        <p:spPr>
+          <a:xfrm>
+            <a:off x="8961120" y="2194560"/>
+            <a:ext cx="2560320" cy="457200"/>
+          </a:xfrm>
+          <a:prstGeom prst="rect">
+            <a:avLst/>
+          </a:prstGeom>
+          <a:noFill/>
+        </p:spPr>
+        <p:txBody>
+          <a:bodyPr wrap="square" lIns="45720" rIns="45720">
+            <a:spAutoFit/>
+          </a:bodyPr>
+          <a:lstStyle/>
+          <a:p>
+            <a:pPr algn="l"/>
+            <a:r>
+              <a:rPr sz="1600" b="1">
+                <a:solidFill>
+                  <a:srgbClr val="1F4E79"/>
+                </a:solidFill>
+              </a:rPr>
+              <a:t>73.1%   (117/160)</a:t>
+            </a:r>
+          </a:p>
+        </p:txBody>
+      </p:sp>
+      <p:sp>
+        <p:nvSpPr>
+          <p:cNvPr id="19" name="TextBox 18"/>
+          <p:cNvSpPr txBox="1"/>
+          <p:nvPr/>
+        </p:nvSpPr>
+        <p:spPr>
+          <a:xfrm>
+            <a:off x="6492240" y="2788920"/>
+            <a:ext cx="2468880" cy="457200"/>
+          </a:xfrm>
+          <a:prstGeom prst="rect">
+            <a:avLst/>
+          </a:prstGeom>
+          <a:noFill/>
+        </p:spPr>
+        <p:txBody>
+          <a:bodyPr wrap="square" lIns="45720" rIns="45720">
+            <a:spAutoFit/>
+          </a:bodyPr>
+          <a:lstStyle/>
+          <a:p>
+            <a:pPr algn="l"/>
+            <a:r>
+              <a:rPr sz="1300" b="1">
+                <a:solidFill>
+                  <a:srgbClr val="34495E"/>
+                </a:solidFill>
+              </a:rPr>
+              <a:t>Found (D + I)</a:t>
+            </a:r>
+          </a:p>
+        </p:txBody>
+      </p:sp>
+      <p:sp>
+        <p:nvSpPr>
+          <p:cNvPr id="20" name="TextBox 19"/>
+          <p:cNvSpPr txBox="1"/>
+          <p:nvPr/>
+        </p:nvSpPr>
+        <p:spPr>
+          <a:xfrm>
+            <a:off x="8961120" y="2788920"/>
+            <a:ext cx="2560320" cy="457200"/>
+          </a:xfrm>
+          <a:prstGeom prst="rect">
+            <a:avLst/>
+          </a:prstGeom>
+          <a:noFill/>
+        </p:spPr>
+        <p:txBody>
+          <a:bodyPr wrap="square" lIns="45720" rIns="45720">
+            <a:spAutoFit/>
+          </a:bodyPr>
+          <a:lstStyle/>
+          <a:p>
+            <a:pPr algn="l"/>
+            <a:r>
+              <a:rPr sz="1600" b="1">
+                <a:solidFill>
+                  <a:srgbClr val="1F4E79"/>
+                </a:solidFill>
+              </a:rPr>
+              <a:t>87.5%   (140/160)</a:t>
+            </a:r>
+          </a:p>
+        </p:txBody>
+      </p:sp>
+      <p:sp>
+        <p:nvSpPr>
+          <p:cNvPr id="21" name="TextBox 20"/>
+          <p:cNvSpPr txBox="1"/>
+          <p:nvPr/>
+        </p:nvSpPr>
+        <p:spPr>
+          <a:xfrm>
+            <a:off x="6492240" y="3383280"/>
+            <a:ext cx="2468880" cy="457200"/>
+          </a:xfrm>
+          <a:prstGeom prst="rect">
+            <a:avLst/>
+          </a:prstGeom>
+          <a:noFill/>
+        </p:spPr>
+        <p:txBody>
+          <a:bodyPr wrap="square" lIns="45720" rIns="45720">
+            <a:spAutoFit/>
+          </a:bodyPr>
+          <a:lstStyle/>
+          <a:p>
+            <a:pPr algn="l"/>
+            <a:r>
+              <a:rPr sz="1300" b="1">
+                <a:solidFill>
+                  <a:srgbClr val="34495E"/>
+                </a:solidFill>
+              </a:rPr>
+              <a:t>MISS</a:t>
+            </a:r>
+          </a:p>
+        </p:txBody>
+      </p:sp>
+      <p:sp>
+        <p:nvSpPr>
+          <p:cNvPr id="22" name="TextBox 21"/>
+          <p:cNvSpPr txBox="1"/>
+          <p:nvPr/>
+        </p:nvSpPr>
+        <p:spPr>
+          <a:xfrm>
+            <a:off x="8961120" y="3383280"/>
+            <a:ext cx="2560320" cy="457200"/>
+          </a:xfrm>
+          <a:prstGeom prst="rect">
+            <a:avLst/>
+          </a:prstGeom>
+          <a:noFill/>
+        </p:spPr>
+        <p:txBody>
+          <a:bodyPr wrap="square" lIns="45720" rIns="45720">
+            <a:spAutoFit/>
+          </a:bodyPr>
+          <a:lstStyle/>
+          <a:p>
+            <a:pPr algn="l"/>
+            <a:r>
+              <a:rPr sz="1600" b="1">
+                <a:solidFill>
+                  <a:srgbClr val="1F4E79"/>
+                </a:solidFill>
+              </a:rPr>
+              <a:t>12.5%   (20/160)</a:t>
+            </a:r>
+          </a:p>
+        </p:txBody>
+      </p:sp>
+      <p:sp>
+        <p:nvSpPr>
+          <p:cNvPr id="23" name="TextBox 22"/>
+          <p:cNvSpPr txBox="1"/>
+          <p:nvPr/>
+        </p:nvSpPr>
+        <p:spPr>
+          <a:xfrm>
+            <a:off x="548640" y="4572000"/>
+            <a:ext cx="11064240" cy="411480"/>
+          </a:xfrm>
+          <a:prstGeom prst="rect">
+            <a:avLst/>
+          </a:prstGeom>
+          <a:noFill/>
+        </p:spPr>
+        <p:txBody>
+          <a:bodyPr wrap="square" lIns="45720" rIns="45720">
+            <a:spAutoFit/>
+          </a:bodyPr>
+          <a:lstStyle/>
+          <a:p>
+            <a:pPr algn="l"/>
             <a:r>
               <a:rPr sz="1400" b="1">
                 <a:solidFill>
-                  <a:srgbClr val="FFFFFF"/>
-                </a:solidFill>
-              </a:rPr>
-              <a:t>2</a:t>
-            </a:r>
-          </a:p>
-        </p:txBody>
-      </p:sp>
-      <p:sp>
-        <p:nvSpPr>
-          <p:cNvPr id="10" name="TextBox 9"/>
-          <p:cNvSpPr txBox="1"/>
-          <p:nvPr/>
-        </p:nvSpPr>
-        <p:spPr>
-          <a:xfrm>
-            <a:off x="8458199" y="2194560"/>
-            <a:ext cx="3840480" cy="411480"/>
-          </a:xfrm>
-          <a:prstGeom prst="rect">
-            <a:avLst/>
-          </a:prstGeom>
-          <a:noFill/>
-        </p:spPr>
-        <p:txBody>
-          <a:bodyPr wrap="square" lIns="45720" rIns="45720">
-            <a:spAutoFit/>
-          </a:bodyPr>
-          <a:lstStyle/>
-          <a:p>
-            <a:pPr algn="l"/>
-            <a:r>
-              <a:rPr sz="1200" b="1">
-                <a:solidFill>
-                  <a:srgbClr val="142B4A"/>
-                </a:solidFill>
-              </a:rPr>
-              <a:t>Similar past cases (Tier-4 recall)</a:t>
-            </a:r>
-          </a:p>
-        </p:txBody>
-      </p:sp>
-      <p:sp>
-        <p:nvSpPr>
-          <p:cNvPr id="11" name="TextBox 10"/>
-          <p:cNvSpPr txBox="1"/>
-          <p:nvPr/>
-        </p:nvSpPr>
-        <p:spPr>
-          <a:xfrm>
-            <a:off x="8458199" y="2560320"/>
-            <a:ext cx="3840480" cy="777240"/>
-          </a:xfrm>
-          <a:prstGeom prst="rect">
-            <a:avLst/>
-          </a:prstGeom>
-          <a:noFill/>
-        </p:spPr>
-        <p:txBody>
-          <a:bodyPr wrap="square" lIns="45720" rIns="45720">
-            <a:spAutoFit/>
-          </a:bodyPr>
-          <a:lstStyle/>
-          <a:p>
-            <a:pPr algn="l"/>
-            <a:r>
-              <a:rPr sz="1000" b="0">
-                <a:solidFill>
                   <a:srgbClr val="34495E"/>
                 </a:solidFill>
               </a:rPr>
-              <a:t>Top-K neighbours with their evaluator match type; one click switches view.</a:t>
-            </a:r>
-          </a:p>
-        </p:txBody>
-      </p:sp>
-      <p:sp>
-        <p:nvSpPr>
-          <p:cNvPr id="12" name="Oval 11"/>
+              <a:t>Δ (Multi-agent − single LLM)</a:t>
+            </a:r>
+          </a:p>
+        </p:txBody>
+      </p:sp>
+      <p:sp>
+        <p:nvSpPr>
+          <p:cNvPr id="24" name="Rounded Rectangle 23"/>
           <p:cNvSpPr/>
           <p:nvPr/>
         </p:nvSpPr>
         <p:spPr>
           <a:xfrm>
-            <a:off x="7955279" y="3383280"/>
-            <a:ext cx="411480" cy="411480"/>
-          </a:xfrm>
-          <a:prstGeom prst="ellipse">
+            <a:off x="548640" y="5029200"/>
+            <a:ext cx="3566160" cy="640080"/>
+          </a:xfrm>
+          <a:prstGeom prst="roundRect">
             <a:avLst/>
           </a:prstGeom>
           <a:solidFill>
-            <a:srgbClr val="D35400"/>
+            <a:srgbClr val="FFFFFF"/>
           </a:solidFill>
-          <a:ln w="19050">
+          <a:ln>
             <a:solidFill>
-              <a:srgbClr val="FFFFFF"/>
+              <a:srgbClr val="ECF0F1"/>
             </a:solidFill>
           </a:ln>
         </p:spPr>
@@ -6078,109 +6481,101 @@
           </a:fontRef>
         </p:style>
         <p:txBody>
-          <a:bodyPr rtlCol="0" anchor="ctr" lIns="0" rIns="0" tIns="0" bIns="0"/>
+          <a:bodyPr rtlCol="0" anchor="ctr"/>
           <a:lstStyle/>
           <a:p>
             <a:pPr algn="ctr"/>
+          </a:p>
+        </p:txBody>
+      </p:sp>
+      <p:sp>
+        <p:nvSpPr>
+          <p:cNvPr id="25" name="TextBox 24"/>
+          <p:cNvSpPr txBox="1"/>
+          <p:nvPr/>
+        </p:nvSpPr>
+        <p:spPr>
+          <a:xfrm>
+            <a:off x="731520" y="5120640"/>
+            <a:ext cx="1371600" cy="457200"/>
+          </a:xfrm>
+          <a:prstGeom prst="rect">
+            <a:avLst/>
+          </a:prstGeom>
+          <a:noFill/>
+        </p:spPr>
+        <p:txBody>
+          <a:bodyPr wrap="square" lIns="45720" rIns="45720">
+            <a:spAutoFit/>
+          </a:bodyPr>
+          <a:lstStyle/>
+          <a:p>
+            <a:pPr algn="l"/>
             <a:r>
               <a:rPr sz="1400" b="1">
                 <a:solidFill>
-                  <a:srgbClr val="FFFFFF"/>
-                </a:solidFill>
-              </a:rPr>
-              <a:t>3</a:t>
-            </a:r>
-          </a:p>
-        </p:txBody>
-      </p:sp>
-      <p:sp>
-        <p:nvSpPr>
-          <p:cNvPr id="13" name="TextBox 12"/>
-          <p:cNvSpPr txBox="1"/>
-          <p:nvPr/>
-        </p:nvSpPr>
-        <p:spPr>
-          <a:xfrm>
-            <a:off x="8458199" y="3337560"/>
-            <a:ext cx="3840480" cy="411480"/>
-          </a:xfrm>
-          <a:prstGeom prst="rect">
-            <a:avLst/>
-          </a:prstGeom>
-          <a:noFill/>
-        </p:spPr>
-        <p:txBody>
-          <a:bodyPr wrap="square" lIns="45720" rIns="45720">
-            <a:spAutoFit/>
-          </a:bodyPr>
-          <a:lstStyle/>
-          <a:p>
-            <a:pPr algn="l"/>
-            <a:r>
-              <a:rPr sz="1200" b="1">
-                <a:solidFill>
-                  <a:srgbClr val="142B4A"/>
-                </a:solidFill>
-              </a:rPr>
-              <a:t>Treatment safety panel</a:t>
-            </a:r>
-          </a:p>
-        </p:txBody>
-      </p:sp>
-      <p:sp>
-        <p:nvSpPr>
-          <p:cNvPr id="14" name="TextBox 13"/>
-          <p:cNvSpPr txBox="1"/>
-          <p:nvPr/>
-        </p:nvSpPr>
-        <p:spPr>
-          <a:xfrm>
-            <a:off x="8458199" y="3703320"/>
-            <a:ext cx="3840480" cy="777240"/>
-          </a:xfrm>
-          <a:prstGeom prst="rect">
-            <a:avLst/>
-          </a:prstGeom>
-          <a:noFill/>
-        </p:spPr>
-        <p:txBody>
-          <a:bodyPr wrap="square" lIns="45720" rIns="45720">
-            <a:spAutoFit/>
-          </a:bodyPr>
-          <a:lstStyle/>
-          <a:p>
-            <a:pPr algn="l"/>
-            <a:r>
-              <a:rPr sz="1000" b="0">
-                <a:solidFill>
                   <a:srgbClr val="34495E"/>
                 </a:solidFill>
               </a:rPr>
-              <a:t>Drugs, interactions, contraindications + planner's assumptions &amp; missing-data warnings.</a:t>
-            </a:r>
-          </a:p>
-        </p:txBody>
-      </p:sp>
-      <p:sp>
-        <p:nvSpPr>
-          <p:cNvPr id="15" name="Oval 14"/>
+              <a:t>DIRECT</a:t>
+            </a:r>
+          </a:p>
+        </p:txBody>
+      </p:sp>
+      <p:sp>
+        <p:nvSpPr>
+          <p:cNvPr id="26" name="TextBox 25"/>
+          <p:cNvSpPr txBox="1"/>
+          <p:nvPr/>
+        </p:nvSpPr>
+        <p:spPr>
+          <a:xfrm>
+            <a:off x="2103120" y="5120640"/>
+            <a:ext cx="1920240" cy="457200"/>
+          </a:xfrm>
+          <a:prstGeom prst="rect">
+            <a:avLst/>
+          </a:prstGeom>
+          <a:noFill/>
+        </p:spPr>
+        <p:txBody>
+          <a:bodyPr wrap="square" lIns="45720" rIns="45720">
+            <a:spAutoFit/>
+          </a:bodyPr>
+          <a:lstStyle/>
+          <a:p>
+            <a:pPr algn="r"/>
+            <a:r>
+              <a:rPr sz="1800" b="1">
+                <a:solidFill>
+                  <a:srgbClr val="27AE60"/>
+                </a:solidFill>
+              </a:rPr>
+              <a:t>+33.1 pp</a:t>
+            </a:r>
+          </a:p>
+        </p:txBody>
+      </p:sp>
+      <p:sp>
+        <p:nvSpPr>
+          <p:cNvPr id="27" name="Rounded Rectangle 26"/>
           <p:cNvSpPr/>
           <p:nvPr/>
         </p:nvSpPr>
         <p:spPr>
           <a:xfrm>
-            <a:off x="7955279" y="4526280"/>
-            <a:ext cx="411480" cy="411480"/>
-          </a:xfrm>
-          <a:prstGeom prst="ellipse">
+            <a:off x="4297679" y="5029200"/>
+            <a:ext cx="3566160" cy="640080"/>
+          </a:xfrm>
+          <a:prstGeom prst="roundRect">
             <a:avLst/>
           </a:prstGeom>
           <a:solidFill>
-            <a:srgbClr val="D35400"/>
+            <a:srgbClr val="FFFFFF"/>
           </a:solidFill>
-          <a:ln w="19050">
+          <a:ln>
             <a:solidFill>
-              <a:srgbClr val="FFFFFF"/>
+              <a:srgbClr val="ECF0F1"/>
             </a:solidFill>
           </a:ln>
         </p:spPr>
@@ -6199,119 +6594,258 @@
           </a:fontRef>
         </p:style>
         <p:txBody>
-          <a:bodyPr rtlCol="0" anchor="ctr" lIns="0" rIns="0" tIns="0" bIns="0"/>
+          <a:bodyPr rtlCol="0" anchor="ctr"/>
           <a:lstStyle/>
           <a:p>
             <a:pPr algn="ctr"/>
+          </a:p>
+        </p:txBody>
+      </p:sp>
+      <p:sp>
+        <p:nvSpPr>
+          <p:cNvPr id="28" name="TextBox 27"/>
+          <p:cNvSpPr txBox="1"/>
+          <p:nvPr/>
+        </p:nvSpPr>
+        <p:spPr>
+          <a:xfrm>
+            <a:off x="4480559" y="5120640"/>
+            <a:ext cx="1371600" cy="457200"/>
+          </a:xfrm>
+          <a:prstGeom prst="rect">
+            <a:avLst/>
+          </a:prstGeom>
+          <a:noFill/>
+        </p:spPr>
+        <p:txBody>
+          <a:bodyPr wrap="square" lIns="45720" rIns="45720">
+            <a:spAutoFit/>
+          </a:bodyPr>
+          <a:lstStyle/>
+          <a:p>
+            <a:pPr algn="l"/>
             <a:r>
               <a:rPr sz="1400" b="1">
                 <a:solidFill>
-                  <a:srgbClr val="FFFFFF"/>
-                </a:solidFill>
-              </a:rPr>
-              <a:t>4</a:t>
-            </a:r>
-          </a:p>
-        </p:txBody>
-      </p:sp>
-      <p:sp>
-        <p:nvSpPr>
-          <p:cNvPr id="16" name="TextBox 15"/>
-          <p:cNvSpPr txBox="1"/>
-          <p:nvPr/>
-        </p:nvSpPr>
-        <p:spPr>
-          <a:xfrm>
-            <a:off x="8458199" y="4480560"/>
-            <a:ext cx="3840480" cy="411480"/>
-          </a:xfrm>
-          <a:prstGeom prst="rect">
-            <a:avLst/>
-          </a:prstGeom>
-          <a:noFill/>
-        </p:spPr>
-        <p:txBody>
-          <a:bodyPr wrap="square" lIns="45720" rIns="45720">
-            <a:spAutoFit/>
-          </a:bodyPr>
-          <a:lstStyle/>
-          <a:p>
-            <a:pPr algn="l"/>
+                  <a:srgbClr val="34495E"/>
+                </a:solidFill>
+              </a:rPr>
+              <a:t>Found</a:t>
+            </a:r>
+          </a:p>
+        </p:txBody>
+      </p:sp>
+      <p:sp>
+        <p:nvSpPr>
+          <p:cNvPr id="29" name="TextBox 28"/>
+          <p:cNvSpPr txBox="1"/>
+          <p:nvPr/>
+        </p:nvSpPr>
+        <p:spPr>
+          <a:xfrm>
+            <a:off x="5852159" y="5120640"/>
+            <a:ext cx="1920240" cy="457200"/>
+          </a:xfrm>
+          <a:prstGeom prst="rect">
+            <a:avLst/>
+          </a:prstGeom>
+          <a:noFill/>
+        </p:spPr>
+        <p:txBody>
+          <a:bodyPr wrap="square" lIns="45720" rIns="45720">
+            <a:spAutoFit/>
+          </a:bodyPr>
+          <a:lstStyle/>
+          <a:p>
+            <a:pPr algn="r"/>
+            <a:r>
+              <a:rPr sz="1800" b="1">
+                <a:solidFill>
+                  <a:srgbClr val="27AE60"/>
+                </a:solidFill>
+              </a:rPr>
+              <a:t>+19.4 pp</a:t>
+            </a:r>
+          </a:p>
+        </p:txBody>
+      </p:sp>
+      <p:sp>
+        <p:nvSpPr>
+          <p:cNvPr id="30" name="Rounded Rectangle 29"/>
+          <p:cNvSpPr/>
+          <p:nvPr/>
+        </p:nvSpPr>
+        <p:spPr>
+          <a:xfrm>
+            <a:off x="8046719" y="5029200"/>
+            <a:ext cx="3566160" cy="640080"/>
+          </a:xfrm>
+          <a:prstGeom prst="roundRect">
+            <a:avLst/>
+          </a:prstGeom>
+          <a:solidFill>
+            <a:srgbClr val="FFFFFF"/>
+          </a:solidFill>
+          <a:ln>
+            <a:solidFill>
+              <a:srgbClr val="ECF0F1"/>
+            </a:solidFill>
+          </a:ln>
+        </p:spPr>
+        <p:style>
+          <a:lnRef idx="1">
+            <a:schemeClr val="accent1"/>
+          </a:lnRef>
+          <a:fillRef idx="3">
+            <a:schemeClr val="accent1"/>
+          </a:fillRef>
+          <a:effectRef idx="2">
+            <a:schemeClr val="accent1"/>
+          </a:effectRef>
+          <a:fontRef idx="minor">
+            <a:schemeClr val="lt1"/>
+          </a:fontRef>
+        </p:style>
+        <p:txBody>
+          <a:bodyPr rtlCol="0" anchor="ctr"/>
+          <a:lstStyle/>
+          <a:p>
+            <a:pPr algn="ctr"/>
+          </a:p>
+        </p:txBody>
+      </p:sp>
+      <p:sp>
+        <p:nvSpPr>
+          <p:cNvPr id="31" name="TextBox 30"/>
+          <p:cNvSpPr txBox="1"/>
+          <p:nvPr/>
+        </p:nvSpPr>
+        <p:spPr>
+          <a:xfrm>
+            <a:off x="8229599" y="5120640"/>
+            <a:ext cx="1371600" cy="457200"/>
+          </a:xfrm>
+          <a:prstGeom prst="rect">
+            <a:avLst/>
+          </a:prstGeom>
+          <a:noFill/>
+        </p:spPr>
+        <p:txBody>
+          <a:bodyPr wrap="square" lIns="45720" rIns="45720">
+            <a:spAutoFit/>
+          </a:bodyPr>
+          <a:lstStyle/>
+          <a:p>
+            <a:pPr algn="l"/>
+            <a:r>
+              <a:rPr sz="1400" b="1">
+                <a:solidFill>
+                  <a:srgbClr val="34495E"/>
+                </a:solidFill>
+              </a:rPr>
+              <a:t>MISS</a:t>
+            </a:r>
+          </a:p>
+        </p:txBody>
+      </p:sp>
+      <p:sp>
+        <p:nvSpPr>
+          <p:cNvPr id="32" name="TextBox 31"/>
+          <p:cNvSpPr txBox="1"/>
+          <p:nvPr/>
+        </p:nvSpPr>
+        <p:spPr>
+          <a:xfrm>
+            <a:off x="9601199" y="5120640"/>
+            <a:ext cx="1920240" cy="457200"/>
+          </a:xfrm>
+          <a:prstGeom prst="rect">
+            <a:avLst/>
+          </a:prstGeom>
+          <a:noFill/>
+        </p:spPr>
+        <p:txBody>
+          <a:bodyPr wrap="square" lIns="45720" rIns="45720">
+            <a:spAutoFit/>
+          </a:bodyPr>
+          <a:lstStyle/>
+          <a:p>
+            <a:pPr algn="r"/>
+            <a:r>
+              <a:rPr sz="1800" b="1">
+                <a:solidFill>
+                  <a:srgbClr val="27AE60"/>
+                </a:solidFill>
+              </a:rPr>
+              <a:t>-19.4 pp</a:t>
+            </a:r>
+          </a:p>
+        </p:txBody>
+      </p:sp>
+      <p:sp>
+        <p:nvSpPr>
+          <p:cNvPr id="33" name="TextBox 32"/>
+          <p:cNvSpPr txBox="1"/>
+          <p:nvPr/>
+        </p:nvSpPr>
+        <p:spPr>
+          <a:xfrm>
+            <a:off x="548640" y="5852160"/>
+            <a:ext cx="11064240" cy="365760"/>
+          </a:xfrm>
+          <a:prstGeom prst="rect">
+            <a:avLst/>
+          </a:prstGeom>
+          <a:noFill/>
+        </p:spPr>
+        <p:txBody>
+          <a:bodyPr wrap="square" lIns="45720" rIns="45720">
+            <a:spAutoFit/>
+          </a:bodyPr>
+          <a:lstStyle/>
+          <a:p>
+            <a:pPr algn="ctr"/>
+            <a:r>
+              <a:rPr sz="1100" b="0">
+                <a:solidFill>
+                  <a:srgbClr val="34495E"/>
+                </a:solidFill>
+              </a:rPr>
+              <a:t>Paired contingency on DIRECT: 48 both · 69 only-multi-agent · 16 only-single-LLM · 27 neither  (85 discordant)</a:t>
+            </a:r>
+          </a:p>
+        </p:txBody>
+      </p:sp>
+      <p:sp>
+        <p:nvSpPr>
+          <p:cNvPr id="34" name="TextBox 33"/>
+          <p:cNvSpPr txBox="1"/>
+          <p:nvPr/>
+        </p:nvSpPr>
+        <p:spPr>
+          <a:xfrm>
+            <a:off x="548640" y="6263640"/>
+            <a:ext cx="11064240" cy="365760"/>
+          </a:xfrm>
+          <a:prstGeom prst="rect">
+            <a:avLst/>
+          </a:prstGeom>
+          <a:noFill/>
+        </p:spPr>
+        <p:txBody>
+          <a:bodyPr wrap="square" lIns="45720" rIns="45720">
+            <a:spAutoFit/>
+          </a:bodyPr>
+          <a:lstStyle/>
+          <a:p>
+            <a:pPr algn="ctr"/>
             <a:r>
               <a:rPr sz="1200" b="1">
                 <a:solidFill>
                   <a:srgbClr val="142B4A"/>
                 </a:solidFill>
               </a:rPr>
-              <a:t>Reviewer note + persistence</a:t>
-            </a:r>
-          </a:p>
-        </p:txBody>
-      </p:sp>
-      <p:sp>
-        <p:nvSpPr>
-          <p:cNvPr id="17" name="TextBox 16"/>
-          <p:cNvSpPr txBox="1"/>
-          <p:nvPr/>
-        </p:nvSpPr>
-        <p:spPr>
-          <a:xfrm>
-            <a:off x="8458199" y="4846320"/>
-            <a:ext cx="3840480" cy="777240"/>
-          </a:xfrm>
-          <a:prstGeom prst="rect">
-            <a:avLst/>
-          </a:prstGeom>
-          <a:noFill/>
-        </p:spPr>
-        <p:txBody>
-          <a:bodyPr wrap="square" lIns="45720" rIns="45720">
-            <a:spAutoFit/>
-          </a:bodyPr>
-          <a:lstStyle/>
-          <a:p>
-            <a:pPr algn="l"/>
-            <a:r>
-              <a:rPr sz="1000" b="0">
-                <a:solidFill>
-                  <a:srgbClr val="34495E"/>
-                </a:solidFill>
-              </a:rPr>
-              <a:t>Three-way verdict, free text, initials → data/gold/annotations/&lt;uuid&gt;.json.</a:t>
-            </a:r>
-          </a:p>
-        </p:txBody>
-      </p:sp>
-      <p:sp>
-        <p:nvSpPr>
-          <p:cNvPr id="18" name="TextBox 17"/>
-          <p:cNvSpPr txBox="1"/>
-          <p:nvPr/>
-        </p:nvSpPr>
-        <p:spPr>
-          <a:xfrm>
-            <a:off x="365760" y="6263640"/>
-            <a:ext cx="11430000" cy="365760"/>
-          </a:xfrm>
-          <a:prstGeom prst="rect">
-            <a:avLst/>
-          </a:prstGeom>
-          <a:noFill/>
-        </p:spPr>
-        <p:txBody>
-          <a:bodyPr wrap="square" lIns="45720" rIns="45720">
-            <a:spAutoFit/>
-          </a:bodyPr>
-          <a:lstStyle/>
-          <a:p>
-            <a:pPr algn="ctr"/>
-            <a:r>
-              <a:rPr sz="1000" b="0">
-                <a:solidFill>
-                  <a:srgbClr val="7F8C8D"/>
-                </a:solidFill>
-              </a:rPr>
-              <a:t>URL-driven state: ?r=&lt;set&gt;&amp;p=&lt;uuid&gt;&amp;a=&lt;agent&gt; makes every view shareable and refresh-safe.</a:t>
+              <a:t>Exact McNemar p &lt; 0.0001  ·  Multi-agent orchestration buys +33 pp DIRECT and +19 pp Found at ~22× wall-clock cost.</a:t>
             </a:r>
           </a:p>
         </p:txBody>
@@ -6449,7 +6983,7 @@
                   <a:srgbClr val="FFFFFF"/>
                 </a:solidFill>
               </a:rPr>
-              <a:t>Where CMADS sits against the literature</a:t>
+              <a:t>Doctor dashboard — features overview</a:t>
             </a:r>
           </a:p>
           <a:p>
@@ -6459,31 +6993,55 @@
                   <a:srgbClr val="ECF0F1"/>
                 </a:solidFill>
               </a:rPr>
-              <a:t>Seven comparators · what they do, their result, and what they leave out</a:t>
-            </a:r>
-          </a:p>
-        </p:txBody>
-      </p:sp>
-      <p:sp>
-        <p:nvSpPr>
-          <p:cNvPr id="5" name="Rounded Rectangle 4"/>
+              <a:t>Four features that make the run reviewable</a:t>
+            </a:r>
+          </a:p>
+        </p:txBody>
+      </p:sp>
+      <p:pic>
+        <p:nvPicPr>
+          <p:cNvPr id="5" name="Picture 4" descr="doctor_console.png"/>
+          <p:cNvPicPr>
+            <a:picLocks noChangeAspect="1"/>
+          </p:cNvPicPr>
+          <p:nvPr/>
+        </p:nvPicPr>
+        <p:blipFill>
+          <a:blip r:embed="rId2"/>
+          <a:stretch>
+            <a:fillRect/>
+          </a:stretch>
+        </p:blipFill>
+        <p:spPr>
+          <a:xfrm>
+            <a:off x="365760" y="1097280"/>
+            <a:ext cx="7315200" cy="4572000"/>
+          </a:xfrm>
+          <a:prstGeom prst="rect">
+            <a:avLst/>
+          </a:prstGeom>
+        </p:spPr>
+      </p:pic>
+      <p:sp>
+        <p:nvSpPr>
+          <p:cNvPr id="6" name="Oval 5"/>
           <p:cNvSpPr/>
           <p:nvPr/>
         </p:nvSpPr>
         <p:spPr>
           <a:xfrm>
-            <a:off x="320040" y="1005840"/>
-            <a:ext cx="5623560" cy="1188719"/>
-          </a:xfrm>
-          <a:prstGeom prst="roundRect">
+            <a:off x="7955279" y="1097280"/>
+            <a:ext cx="411480" cy="411480"/>
+          </a:xfrm>
+          <a:prstGeom prst="ellipse">
             <a:avLst/>
           </a:prstGeom>
           <a:solidFill>
-            <a:srgbClr val="FFFFFF"/>
+            <a:srgbClr val="D35400"/>
           </a:solidFill>
-          <a:ln w="15875">
+          <a:ln w="19050">
             <a:solidFill>
-              <a:srgbClr val="1F4E79"/>
+              <a:srgbClr val="FFFFFF"/>
             </a:solidFill>
           </a:ln>
         </p:spPr>
@@ -6502,23 +7060,31 @@
           </a:fontRef>
         </p:style>
         <p:txBody>
-          <a:bodyPr rtlCol="0" anchor="ctr"/>
+          <a:bodyPr rtlCol="0" anchor="ctr" lIns="0" rIns="0" tIns="0" bIns="0"/>
           <a:lstStyle/>
           <a:p>
             <a:pPr algn="ctr"/>
-          </a:p>
-        </p:txBody>
-      </p:sp>
-      <p:sp>
-        <p:nvSpPr>
-          <p:cNvPr id="6" name="TextBox 5"/>
-          <p:cNvSpPr txBox="1"/>
-          <p:nvPr/>
-        </p:nvSpPr>
-        <p:spPr>
-          <a:xfrm>
-            <a:off x="457200" y="1051560"/>
-            <a:ext cx="5394960" cy="329184"/>
+            <a:r>
+              <a:rPr sz="1400" b="1">
+                <a:solidFill>
+                  <a:srgbClr val="FFFFFF"/>
+                </a:solidFill>
+              </a:rPr>
+              <a:t>1</a:t>
+            </a:r>
+          </a:p>
+        </p:txBody>
+      </p:sp>
+      <p:sp>
+        <p:nvSpPr>
+          <p:cNvPr id="7" name="TextBox 6"/>
+          <p:cNvSpPr txBox="1"/>
+          <p:nvPr/>
+        </p:nvSpPr>
+        <p:spPr>
+          <a:xfrm>
+            <a:off x="8458199" y="1051560"/>
+            <a:ext cx="3840480" cy="411480"/>
           </a:xfrm>
           <a:prstGeom prst="rect">
             <a:avLst/>
@@ -6535,136 +7101,68 @@
             <a:r>
               <a:rPr sz="1200" b="1">
                 <a:solidFill>
-                  <a:srgbClr val="1F4E79"/>
-                </a:solidFill>
-              </a:rPr>
-              <a:t>AMIE (Tu 2024)</a:t>
-            </a:r>
-          </a:p>
-        </p:txBody>
-      </p:sp>
-      <p:sp>
-        <p:nvSpPr>
-          <p:cNvPr id="7" name="TextBox 6"/>
-          <p:cNvSpPr txBox="1"/>
-          <p:nvPr/>
-        </p:nvSpPr>
-        <p:spPr>
-          <a:xfrm>
-            <a:off x="457200" y="1353312"/>
-            <a:ext cx="5394960" cy="320040"/>
-          </a:xfrm>
-          <a:prstGeom prst="rect">
-            <a:avLst/>
-          </a:prstGeom>
-          <a:noFill/>
-        </p:spPr>
-        <p:txBody>
-          <a:bodyPr wrap="square" lIns="45720" rIns="45720">
-            <a:spAutoFit/>
-          </a:bodyPr>
-          <a:lstStyle/>
-          <a:p>
-            <a:pPr algn="l"/>
-            <a:r>
-              <a:rPr sz="900" b="0">
+                  <a:srgbClr val="142B4A"/>
+                </a:solidFill>
+              </a:rPr>
+              <a:t>Agent workflow inline</a:t>
+            </a:r>
+          </a:p>
+        </p:txBody>
+      </p:sp>
+      <p:sp>
+        <p:nvSpPr>
+          <p:cNvPr id="8" name="TextBox 7"/>
+          <p:cNvSpPr txBox="1"/>
+          <p:nvPr/>
+        </p:nvSpPr>
+        <p:spPr>
+          <a:xfrm>
+            <a:off x="8458199" y="1417319"/>
+            <a:ext cx="3840480" cy="777240"/>
+          </a:xfrm>
+          <a:prstGeom prst="rect">
+            <a:avLst/>
+          </a:prstGeom>
+          <a:noFill/>
+        </p:spPr>
+        <p:txBody>
+          <a:bodyPr wrap="square" lIns="45720" rIns="45720">
+            <a:spAutoFit/>
+          </a:bodyPr>
+          <a:lstStyle/>
+          <a:p>
+            <a:pPr algn="l"/>
+            <a:r>
+              <a:rPr sz="1000" b="0">
                 <a:solidFill>
                   <a:srgbClr val="34495E"/>
                 </a:solidFill>
               </a:rPr>
-              <a:t>Conversational diagnostic AI; OSCE-style consultations.</a:t>
-            </a:r>
-          </a:p>
-        </p:txBody>
-      </p:sp>
-      <p:sp>
-        <p:nvSpPr>
-          <p:cNvPr id="8" name="TextBox 7"/>
-          <p:cNvSpPr txBox="1"/>
-          <p:nvPr/>
-        </p:nvSpPr>
-        <p:spPr>
-          <a:xfrm>
-            <a:off x="457200" y="1645920"/>
-            <a:ext cx="5394960" cy="320040"/>
-          </a:xfrm>
-          <a:prstGeom prst="rect">
-            <a:avLst/>
-          </a:prstGeom>
-          <a:noFill/>
-        </p:spPr>
-        <p:txBody>
-          <a:bodyPr wrap="square" lIns="45720" rIns="45720">
-            <a:spAutoFit/>
-          </a:bodyPr>
-          <a:lstStyle/>
-          <a:p>
-            <a:pPr algn="l"/>
-            <a:r>
-              <a:rPr sz="900" b="1">
-                <a:solidFill>
-                  <a:srgbClr val="34495E"/>
-                </a:solidFill>
-              </a:rPr>
-              <a:t>Result: Beat PCPs on 28/32 specialist axes (149 cases · 20 PCPs).</a:t>
-            </a:r>
-          </a:p>
-        </p:txBody>
-      </p:sp>
-      <p:sp>
-        <p:nvSpPr>
-          <p:cNvPr id="9" name="TextBox 8"/>
-          <p:cNvSpPr txBox="1"/>
-          <p:nvPr/>
-        </p:nvSpPr>
-        <p:spPr>
-          <a:xfrm>
-            <a:off x="457200" y="1920240"/>
-            <a:ext cx="5394960" cy="320040"/>
-          </a:xfrm>
-          <a:prstGeom prst="rect">
-            <a:avLst/>
-          </a:prstGeom>
-          <a:noFill/>
-        </p:spPr>
-        <p:txBody>
-          <a:bodyPr wrap="square" lIns="45720" rIns="45720">
-            <a:spAutoFit/>
-          </a:bodyPr>
-          <a:lstStyle/>
-          <a:p>
-            <a:pPr algn="l"/>
-            <a:r>
-              <a:rPr sz="900" b="0">
-                <a:solidFill>
-                  <a:srgbClr val="C0392B"/>
-                </a:solidFill>
-              </a:rPr>
-              <a:t>Missing: Closed-source backbone · no doctor UI · no inspectable memory.</a:t>
-            </a:r>
-          </a:p>
-        </p:txBody>
-      </p:sp>
-      <p:sp>
-        <p:nvSpPr>
-          <p:cNvPr id="10" name="Rounded Rectangle 9"/>
+              <a:t>Every stage's output one click away, rendered as a doctor-readable narrative.</a:t>
+            </a:r>
+          </a:p>
+        </p:txBody>
+      </p:sp>
+      <p:sp>
+        <p:nvSpPr>
+          <p:cNvPr id="9" name="Oval 8"/>
           <p:cNvSpPr/>
           <p:nvPr/>
         </p:nvSpPr>
         <p:spPr>
           <a:xfrm>
-            <a:off x="320040" y="2286000"/>
-            <a:ext cx="5623560" cy="1188719"/>
-          </a:xfrm>
-          <a:prstGeom prst="roundRect">
+            <a:off x="7955279" y="2240280"/>
+            <a:ext cx="411480" cy="411480"/>
+          </a:xfrm>
+          <a:prstGeom prst="ellipse">
             <a:avLst/>
           </a:prstGeom>
           <a:solidFill>
-            <a:srgbClr val="FFFFFF"/>
+            <a:srgbClr val="D35400"/>
           </a:solidFill>
-          <a:ln w="15875">
+          <a:ln w="19050">
             <a:solidFill>
-              <a:srgbClr val="16A085"/>
+              <a:srgbClr val="FFFFFF"/>
             </a:solidFill>
           </a:ln>
         </p:spPr>
@@ -6683,10 +7181,52 @@
           </a:fontRef>
         </p:style>
         <p:txBody>
-          <a:bodyPr rtlCol="0" anchor="ctr"/>
+          <a:bodyPr rtlCol="0" anchor="ctr" lIns="0" rIns="0" tIns="0" bIns="0"/>
           <a:lstStyle/>
           <a:p>
             <a:pPr algn="ctr"/>
+            <a:r>
+              <a:rPr sz="1400" b="1">
+                <a:solidFill>
+                  <a:srgbClr val="FFFFFF"/>
+                </a:solidFill>
+              </a:rPr>
+              <a:t>2</a:t>
+            </a:r>
+          </a:p>
+        </p:txBody>
+      </p:sp>
+      <p:sp>
+        <p:nvSpPr>
+          <p:cNvPr id="10" name="TextBox 9"/>
+          <p:cNvSpPr txBox="1"/>
+          <p:nvPr/>
+        </p:nvSpPr>
+        <p:spPr>
+          <a:xfrm>
+            <a:off x="8458199" y="2194560"/>
+            <a:ext cx="3840480" cy="411480"/>
+          </a:xfrm>
+          <a:prstGeom prst="rect">
+            <a:avLst/>
+          </a:prstGeom>
+          <a:noFill/>
+        </p:spPr>
+        <p:txBody>
+          <a:bodyPr wrap="square" lIns="45720" rIns="45720">
+            <a:spAutoFit/>
+          </a:bodyPr>
+          <a:lstStyle/>
+          <a:p>
+            <a:pPr algn="l"/>
+            <a:r>
+              <a:rPr sz="1200" b="1">
+                <a:solidFill>
+                  <a:srgbClr val="142B4A"/>
+                </a:solidFill>
+              </a:rPr>
+              <a:t>Similar past cases (Tier-4 recall)</a:t>
+            </a:r>
           </a:p>
         </p:txBody>
       </p:sp>
@@ -6698,154 +7238,52 @@
         </p:nvSpPr>
         <p:spPr>
           <a:xfrm>
-            <a:off x="457200" y="2331720"/>
-            <a:ext cx="5394960" cy="329184"/>
-          </a:xfrm>
-          <a:prstGeom prst="rect">
-            <a:avLst/>
-          </a:prstGeom>
-          <a:noFill/>
-        </p:spPr>
-        <p:txBody>
-          <a:bodyPr wrap="square" lIns="45720" rIns="45720">
-            <a:spAutoFit/>
-          </a:bodyPr>
-          <a:lstStyle/>
-          <a:p>
-            <a:pPr algn="l"/>
-            <a:r>
-              <a:rPr sz="1200" b="1">
-                <a:solidFill>
-                  <a:srgbClr val="16A085"/>
-                </a:solidFill>
-              </a:rPr>
-              <a:t>AgentClinic (Schmidgall 2024)</a:t>
-            </a:r>
-          </a:p>
-        </p:txBody>
-      </p:sp>
-      <p:sp>
-        <p:nvSpPr>
-          <p:cNvPr id="12" name="TextBox 11"/>
-          <p:cNvSpPr txBox="1"/>
-          <p:nvPr/>
-        </p:nvSpPr>
-        <p:spPr>
-          <a:xfrm>
-            <a:off x="457200" y="2633472"/>
-            <a:ext cx="5394960" cy="320040"/>
-          </a:xfrm>
-          <a:prstGeom prst="rect">
-            <a:avLst/>
-          </a:prstGeom>
-          <a:noFill/>
-        </p:spPr>
-        <p:txBody>
-          <a:bodyPr wrap="square" lIns="45720" rIns="45720">
-            <a:spAutoFit/>
-          </a:bodyPr>
-          <a:lstStyle/>
-          <a:p>
-            <a:pPr algn="l"/>
-            <a:r>
-              <a:rPr sz="900" b="0">
+            <a:off x="8458199" y="2560320"/>
+            <a:ext cx="3840480" cy="777240"/>
+          </a:xfrm>
+          <a:prstGeom prst="rect">
+            <a:avLst/>
+          </a:prstGeom>
+          <a:noFill/>
+        </p:spPr>
+        <p:txBody>
+          <a:bodyPr wrap="square" lIns="45720" rIns="45720">
+            <a:spAutoFit/>
+          </a:bodyPr>
+          <a:lstStyle/>
+          <a:p>
+            <a:pPr algn="l"/>
+            <a:r>
+              <a:rPr sz="1000" b="0">
                 <a:solidFill>
                   <a:srgbClr val="34495E"/>
                 </a:solidFill>
               </a:rPr>
-              <a:t>Multimodal benchmark of LLM agents in simulated clinics.</a:t>
-            </a:r>
-          </a:p>
-        </p:txBody>
-      </p:sp>
-      <p:sp>
-        <p:nvSpPr>
-          <p:cNvPr id="13" name="TextBox 12"/>
-          <p:cNvSpPr txBox="1"/>
-          <p:nvPr/>
-        </p:nvSpPr>
-        <p:spPr>
-          <a:xfrm>
-            <a:off x="457200" y="2926080"/>
-            <a:ext cx="5394960" cy="320040"/>
-          </a:xfrm>
-          <a:prstGeom prst="rect">
-            <a:avLst/>
-          </a:prstGeom>
-          <a:noFill/>
-        </p:spPr>
-        <p:txBody>
-          <a:bodyPr wrap="square" lIns="45720" rIns="45720">
-            <a:spAutoFit/>
-          </a:bodyPr>
-          <a:lstStyle/>
-          <a:p>
-            <a:pPr algn="l"/>
-            <a:r>
-              <a:rPr sz="900" b="1">
-                <a:solidFill>
-                  <a:srgbClr val="34495E"/>
-                </a:solidFill>
-              </a:rPr>
-              <a:t>Result: Claude-3.5: 62.1% on AgentClinic-MedQA · PCPs 54%±28.5.</a:t>
-            </a:r>
-          </a:p>
-        </p:txBody>
-      </p:sp>
-      <p:sp>
-        <p:nvSpPr>
-          <p:cNvPr id="14" name="TextBox 13"/>
-          <p:cNvSpPr txBox="1"/>
-          <p:nvPr/>
-        </p:nvSpPr>
-        <p:spPr>
-          <a:xfrm>
-            <a:off x="457200" y="3200400"/>
-            <a:ext cx="5394960" cy="320040"/>
-          </a:xfrm>
-          <a:prstGeom prst="rect">
-            <a:avLst/>
-          </a:prstGeom>
-          <a:noFill/>
-        </p:spPr>
-        <p:txBody>
-          <a:bodyPr wrap="square" lIns="45720" rIns="45720">
-            <a:spAutoFit/>
-          </a:bodyPr>
-          <a:lstStyle/>
-          <a:p>
-            <a:pPr algn="l"/>
-            <a:r>
-              <a:rPr sz="900" b="0">
-                <a:solidFill>
-                  <a:srgbClr val="C0392B"/>
-                </a:solidFill>
-              </a:rPr>
-              <a:t>Missing: Benchmark of others, not a deployed pipeline · no treatment plan.</a:t>
-            </a:r>
-          </a:p>
-        </p:txBody>
-      </p:sp>
-      <p:sp>
-        <p:nvSpPr>
-          <p:cNvPr id="15" name="Rounded Rectangle 14"/>
+              <a:t>Top-K neighbours with their evaluator match type; one click switches view.</a:t>
+            </a:r>
+          </a:p>
+        </p:txBody>
+      </p:sp>
+      <p:sp>
+        <p:nvSpPr>
+          <p:cNvPr id="12" name="Oval 11"/>
           <p:cNvSpPr/>
           <p:nvPr/>
         </p:nvSpPr>
         <p:spPr>
           <a:xfrm>
-            <a:off x="320040" y="3566160"/>
-            <a:ext cx="5623560" cy="1188719"/>
-          </a:xfrm>
-          <a:prstGeom prst="roundRect">
+            <a:off x="7955279" y="3383280"/>
+            <a:ext cx="411480" cy="411480"/>
+          </a:xfrm>
+          <a:prstGeom prst="ellipse">
             <a:avLst/>
           </a:prstGeom>
           <a:solidFill>
-            <a:srgbClr val="FFFFFF"/>
+            <a:srgbClr val="D35400"/>
           </a:solidFill>
-          <a:ln w="15875">
+          <a:ln w="19050">
             <a:solidFill>
-              <a:srgbClr val="142B4A"/>
+              <a:srgbClr val="FFFFFF"/>
             </a:solidFill>
           </a:ln>
         </p:spPr>
@@ -6864,23 +7302,31 @@
           </a:fontRef>
         </p:style>
         <p:txBody>
-          <a:bodyPr rtlCol="0" anchor="ctr"/>
+          <a:bodyPr rtlCol="0" anchor="ctr" lIns="0" rIns="0" tIns="0" bIns="0"/>
           <a:lstStyle/>
           <a:p>
             <a:pPr algn="ctr"/>
-          </a:p>
-        </p:txBody>
-      </p:sp>
-      <p:sp>
-        <p:nvSpPr>
-          <p:cNvPr id="16" name="TextBox 15"/>
-          <p:cNvSpPr txBox="1"/>
-          <p:nvPr/>
-        </p:nvSpPr>
-        <p:spPr>
-          <a:xfrm>
-            <a:off x="457200" y="3611879"/>
-            <a:ext cx="5394960" cy="329184"/>
+            <a:r>
+              <a:rPr sz="1400" b="1">
+                <a:solidFill>
+                  <a:srgbClr val="FFFFFF"/>
+                </a:solidFill>
+              </a:rPr>
+              <a:t>3</a:t>
+            </a:r>
+          </a:p>
+        </p:txBody>
+      </p:sp>
+      <p:sp>
+        <p:nvSpPr>
+          <p:cNvPr id="13" name="TextBox 12"/>
+          <p:cNvSpPr txBox="1"/>
+          <p:nvPr/>
+        </p:nvSpPr>
+        <p:spPr>
+          <a:xfrm>
+            <a:off x="8458199" y="3337560"/>
+            <a:ext cx="3840480" cy="411480"/>
           </a:xfrm>
           <a:prstGeom prst="rect">
             <a:avLst/>
@@ -6900,133 +7346,65 @@
                   <a:srgbClr val="142B4A"/>
                 </a:solidFill>
               </a:rPr>
-              <a:t>MedAgents (Tang 2024, ACL)</a:t>
-            </a:r>
-          </a:p>
-        </p:txBody>
-      </p:sp>
-      <p:sp>
-        <p:nvSpPr>
-          <p:cNvPr id="17" name="TextBox 16"/>
-          <p:cNvSpPr txBox="1"/>
-          <p:nvPr/>
-        </p:nvSpPr>
-        <p:spPr>
-          <a:xfrm>
-            <a:off x="457200" y="3913632"/>
-            <a:ext cx="5394960" cy="320040"/>
-          </a:xfrm>
-          <a:prstGeom prst="rect">
-            <a:avLst/>
-          </a:prstGeom>
-          <a:noFill/>
-        </p:spPr>
-        <p:txBody>
-          <a:bodyPr wrap="square" lIns="45720" rIns="45720">
-            <a:spAutoFit/>
-          </a:bodyPr>
-          <a:lstStyle/>
-          <a:p>
-            <a:pPr algn="l"/>
-            <a:r>
-              <a:rPr sz="900" b="0">
+              <a:t>Treatment safety panel</a:t>
+            </a:r>
+          </a:p>
+        </p:txBody>
+      </p:sp>
+      <p:sp>
+        <p:nvSpPr>
+          <p:cNvPr id="14" name="TextBox 13"/>
+          <p:cNvSpPr txBox="1"/>
+          <p:nvPr/>
+        </p:nvSpPr>
+        <p:spPr>
+          <a:xfrm>
+            <a:off x="8458199" y="3703320"/>
+            <a:ext cx="3840480" cy="777240"/>
+          </a:xfrm>
+          <a:prstGeom prst="rect">
+            <a:avLst/>
+          </a:prstGeom>
+          <a:noFill/>
+        </p:spPr>
+        <p:txBody>
+          <a:bodyPr wrap="square" lIns="45720" rIns="45720">
+            <a:spAutoFit/>
+          </a:bodyPr>
+          <a:lstStyle/>
+          <a:p>
+            <a:pPr algn="l"/>
+            <a:r>
+              <a:rPr sz="1000" b="0">
                 <a:solidFill>
                   <a:srgbClr val="34495E"/>
                 </a:solidFill>
               </a:rPr>
-              <a:t>Multi-agent CoT for zero-shot medical reasoning.</a:t>
-            </a:r>
-          </a:p>
-        </p:txBody>
-      </p:sp>
-      <p:sp>
-        <p:nvSpPr>
-          <p:cNvPr id="18" name="TextBox 17"/>
-          <p:cNvSpPr txBox="1"/>
-          <p:nvPr/>
-        </p:nvSpPr>
-        <p:spPr>
-          <a:xfrm>
-            <a:off x="457200" y="4206240"/>
-            <a:ext cx="5394960" cy="320040"/>
-          </a:xfrm>
-          <a:prstGeom prst="rect">
-            <a:avLst/>
-          </a:prstGeom>
-          <a:noFill/>
-        </p:spPr>
-        <p:txBody>
-          <a:bodyPr wrap="square" lIns="45720" rIns="45720">
-            <a:spAutoFit/>
-          </a:bodyPr>
-          <a:lstStyle/>
-          <a:p>
-            <a:pPr algn="l"/>
-            <a:r>
-              <a:rPr sz="900" b="1">
-                <a:solidFill>
-                  <a:srgbClr val="34495E"/>
-                </a:solidFill>
-              </a:rPr>
-              <a:t>Result: GPT-4: 86.7% avg on 9 MCQ benchmarks (MedQA 83.7%).</a:t>
-            </a:r>
-          </a:p>
-        </p:txBody>
-      </p:sp>
-      <p:sp>
-        <p:nvSpPr>
-          <p:cNvPr id="19" name="TextBox 18"/>
-          <p:cNvSpPr txBox="1"/>
-          <p:nvPr/>
-        </p:nvSpPr>
-        <p:spPr>
-          <a:xfrm>
-            <a:off x="457200" y="4480560"/>
-            <a:ext cx="5394960" cy="320040"/>
-          </a:xfrm>
-          <a:prstGeom prst="rect">
-            <a:avLst/>
-          </a:prstGeom>
-          <a:noFill/>
-        </p:spPr>
-        <p:txBody>
-          <a:bodyPr wrap="square" lIns="45720" rIns="45720">
-            <a:spAutoFit/>
-          </a:bodyPr>
-          <a:lstStyle/>
-          <a:p>
-            <a:pPr algn="l"/>
-            <a:r>
-              <a:rPr sz="900" b="0">
-                <a:solidFill>
-                  <a:srgbClr val="C0392B"/>
-                </a:solidFill>
-              </a:rPr>
-              <a:t>Missing: MCQ-only · no patient data · no memory · no UI.</a:t>
-            </a:r>
-          </a:p>
-        </p:txBody>
-      </p:sp>
-      <p:sp>
-        <p:nvSpPr>
-          <p:cNvPr id="20" name="Rounded Rectangle 19"/>
+              <a:t>Drugs, interactions, contraindications + planner's assumptions &amp; missing-data warnings.</a:t>
+            </a:r>
+          </a:p>
+        </p:txBody>
+      </p:sp>
+      <p:sp>
+        <p:nvSpPr>
+          <p:cNvPr id="15" name="Oval 14"/>
           <p:cNvSpPr/>
           <p:nvPr/>
         </p:nvSpPr>
         <p:spPr>
           <a:xfrm>
-            <a:off x="320040" y="4846319"/>
-            <a:ext cx="5623560" cy="1188719"/>
-          </a:xfrm>
-          <a:prstGeom prst="roundRect">
+            <a:off x="7955279" y="4526280"/>
+            <a:ext cx="411480" cy="411480"/>
+          </a:xfrm>
+          <a:prstGeom prst="ellipse">
             <a:avLst/>
           </a:prstGeom>
           <a:solidFill>
-            <a:srgbClr val="FFFFFF"/>
+            <a:srgbClr val="D35400"/>
           </a:solidFill>
-          <a:ln w="15875">
+          <a:ln w="19050">
             <a:solidFill>
-              <a:srgbClr val="D35400"/>
+              <a:srgbClr val="FFFFFF"/>
             </a:solidFill>
           </a:ln>
         </p:spPr>
@@ -7045,23 +7423,31 @@
           </a:fontRef>
         </p:style>
         <p:txBody>
-          <a:bodyPr rtlCol="0" anchor="ctr"/>
+          <a:bodyPr rtlCol="0" anchor="ctr" lIns="0" rIns="0" tIns="0" bIns="0"/>
           <a:lstStyle/>
           <a:p>
             <a:pPr algn="ctr"/>
-          </a:p>
-        </p:txBody>
-      </p:sp>
-      <p:sp>
-        <p:nvSpPr>
-          <p:cNvPr id="21" name="TextBox 20"/>
-          <p:cNvSpPr txBox="1"/>
-          <p:nvPr/>
-        </p:nvSpPr>
-        <p:spPr>
-          <a:xfrm>
-            <a:off x="457200" y="4892039"/>
-            <a:ext cx="5394960" cy="329184"/>
+            <a:r>
+              <a:rPr sz="1400" b="1">
+                <a:solidFill>
+                  <a:srgbClr val="FFFFFF"/>
+                </a:solidFill>
+              </a:rPr>
+              <a:t>4</a:t>
+            </a:r>
+          </a:p>
+        </p:txBody>
+      </p:sp>
+      <p:sp>
+        <p:nvSpPr>
+          <p:cNvPr id="16" name="TextBox 15"/>
+          <p:cNvSpPr txBox="1"/>
+          <p:nvPr/>
+        </p:nvSpPr>
+        <p:spPr>
+          <a:xfrm>
+            <a:off x="8458199" y="4480560"/>
+            <a:ext cx="3840480" cy="411480"/>
           </a:xfrm>
           <a:prstGeom prst="rect">
             <a:avLst/>
@@ -7078,689 +7464,78 @@
             <a:r>
               <a:rPr sz="1200" b="1">
                 <a:solidFill>
-                  <a:srgbClr val="D35400"/>
-                </a:solidFill>
-              </a:rPr>
-              <a:t>MDTeamGPT (Chen 2025)</a:t>
-            </a:r>
-          </a:p>
-        </p:txBody>
-      </p:sp>
-      <p:sp>
-        <p:nvSpPr>
-          <p:cNvPr id="22" name="TextBox 21"/>
-          <p:cNvSpPr txBox="1"/>
-          <p:nvPr/>
-        </p:nvSpPr>
-        <p:spPr>
-          <a:xfrm>
-            <a:off x="457200" y="5193791"/>
-            <a:ext cx="5394960" cy="320040"/>
-          </a:xfrm>
-          <a:prstGeom prst="rect">
-            <a:avLst/>
-          </a:prstGeom>
-          <a:noFill/>
-        </p:spPr>
-        <p:txBody>
-          <a:bodyPr wrap="square" lIns="45720" rIns="45720">
-            <a:spAutoFit/>
-          </a:bodyPr>
-          <a:lstStyle/>
-          <a:p>
-            <a:pPr algn="l"/>
-            <a:r>
-              <a:rPr sz="900" b="0">
+                  <a:srgbClr val="142B4A"/>
+                </a:solidFill>
+              </a:rPr>
+              <a:t>Reviewer note + persistence</a:t>
+            </a:r>
+          </a:p>
+        </p:txBody>
+      </p:sp>
+      <p:sp>
+        <p:nvSpPr>
+          <p:cNvPr id="17" name="TextBox 16"/>
+          <p:cNvSpPr txBox="1"/>
+          <p:nvPr/>
+        </p:nvSpPr>
+        <p:spPr>
+          <a:xfrm>
+            <a:off x="8458199" y="4846320"/>
+            <a:ext cx="3840480" cy="777240"/>
+          </a:xfrm>
+          <a:prstGeom prst="rect">
+            <a:avLst/>
+          </a:prstGeom>
+          <a:noFill/>
+        </p:spPr>
+        <p:txBody>
+          <a:bodyPr wrap="square" lIns="45720" rIns="45720">
+            <a:spAutoFit/>
+          </a:bodyPr>
+          <a:lstStyle/>
+          <a:p>
+            <a:pPr algn="l"/>
+            <a:r>
+              <a:rPr sz="1000" b="0">
                 <a:solidFill>
                   <a:srgbClr val="34495E"/>
                 </a:solidFill>
               </a:rPr>
-              <a:t>Self-evolving MDT with CorrectKB + ChainKB.</a:t>
-            </a:r>
-          </a:p>
-        </p:txBody>
-      </p:sp>
-      <p:sp>
-        <p:nvSpPr>
-          <p:cNvPr id="23" name="TextBox 22"/>
-          <p:cNvSpPr txBox="1"/>
-          <p:nvPr/>
-        </p:nvSpPr>
-        <p:spPr>
-          <a:xfrm>
-            <a:off x="457200" y="5486399"/>
-            <a:ext cx="5394960" cy="320040"/>
-          </a:xfrm>
-          <a:prstGeom prst="rect">
-            <a:avLst/>
-          </a:prstGeom>
-          <a:noFill/>
-        </p:spPr>
-        <p:txBody>
-          <a:bodyPr wrap="square" lIns="45720" rIns="45720">
-            <a:spAutoFit/>
-          </a:bodyPr>
-          <a:lstStyle/>
-          <a:p>
-            <a:pPr algn="l"/>
-            <a:r>
-              <a:rPr sz="900" b="1">
-                <a:solidFill>
-                  <a:srgbClr val="34495E"/>
-                </a:solidFill>
-              </a:rPr>
-              <a:t>Result: 90.1% on MedQA · 83.9% on PubMedQA.</a:t>
-            </a:r>
-          </a:p>
-        </p:txBody>
-      </p:sp>
-      <p:sp>
-        <p:nvSpPr>
-          <p:cNvPr id="24" name="TextBox 23"/>
-          <p:cNvSpPr txBox="1"/>
-          <p:nvPr/>
-        </p:nvSpPr>
-        <p:spPr>
-          <a:xfrm>
-            <a:off x="457200" y="5760719"/>
-            <a:ext cx="5394960" cy="320040"/>
-          </a:xfrm>
-          <a:prstGeom prst="rect">
-            <a:avLst/>
-          </a:prstGeom>
-          <a:noFill/>
-        </p:spPr>
-        <p:txBody>
-          <a:bodyPr wrap="square" lIns="45720" rIns="45720">
-            <a:spAutoFit/>
-          </a:bodyPr>
-          <a:lstStyle/>
-          <a:p>
-            <a:pPr algn="l"/>
-            <a:r>
-              <a:rPr sz="900" b="0">
-                <a:solidFill>
-                  <a:srgbClr val="C0392B"/>
-                </a:solidFill>
-              </a:rPr>
-              <a:t>Missing: MCQ-only · no end-to-end pipeline · no clinician interface.</a:t>
-            </a:r>
-          </a:p>
-        </p:txBody>
-      </p:sp>
-      <p:sp>
-        <p:nvSpPr>
-          <p:cNvPr id="25" name="Rounded Rectangle 24"/>
-          <p:cNvSpPr/>
-          <p:nvPr/>
-        </p:nvSpPr>
-        <p:spPr>
-          <a:xfrm>
-            <a:off x="6263640" y="1005840"/>
-            <a:ext cx="5623560" cy="1188719"/>
-          </a:xfrm>
-          <a:prstGeom prst="roundRect">
-            <a:avLst/>
-          </a:prstGeom>
-          <a:solidFill>
-            <a:srgbClr val="FFFFFF"/>
-          </a:solidFill>
-          <a:ln w="15875">
-            <a:solidFill>
-              <a:srgbClr val="27AE60"/>
-            </a:solidFill>
-          </a:ln>
-        </p:spPr>
-        <p:style>
-          <a:lnRef idx="1">
-            <a:schemeClr val="accent1"/>
-          </a:lnRef>
-          <a:fillRef idx="3">
-            <a:schemeClr val="accent1"/>
-          </a:fillRef>
-          <a:effectRef idx="2">
-            <a:schemeClr val="accent1"/>
-          </a:effectRef>
-          <a:fontRef idx="minor">
-            <a:schemeClr val="lt1"/>
-          </a:fontRef>
-        </p:style>
-        <p:txBody>
-          <a:bodyPr rtlCol="0" anchor="ctr"/>
+              <a:t>Three-way verdict, free text, initials → data/gold/annotations/&lt;uuid&gt;.json.</a:t>
+            </a:r>
+          </a:p>
+        </p:txBody>
+      </p:sp>
+      <p:sp>
+        <p:nvSpPr>
+          <p:cNvPr id="18" name="TextBox 17"/>
+          <p:cNvSpPr txBox="1"/>
+          <p:nvPr/>
+        </p:nvSpPr>
+        <p:spPr>
+          <a:xfrm>
+            <a:off x="365760" y="6263640"/>
+            <a:ext cx="11430000" cy="365760"/>
+          </a:xfrm>
+          <a:prstGeom prst="rect">
+            <a:avLst/>
+          </a:prstGeom>
+          <a:noFill/>
+        </p:spPr>
+        <p:txBody>
+          <a:bodyPr wrap="square" lIns="45720" rIns="45720">
+            <a:spAutoFit/>
+          </a:bodyPr>
           <a:lstStyle/>
           <a:p>
             <a:pPr algn="ctr"/>
-          </a:p>
-        </p:txBody>
-      </p:sp>
-      <p:sp>
-        <p:nvSpPr>
-          <p:cNvPr id="26" name="TextBox 25"/>
-          <p:cNvSpPr txBox="1"/>
-          <p:nvPr/>
-        </p:nvSpPr>
-        <p:spPr>
-          <a:xfrm>
-            <a:off x="6400800" y="1051560"/>
-            <a:ext cx="5394960" cy="329184"/>
-          </a:xfrm>
-          <a:prstGeom prst="rect">
-            <a:avLst/>
-          </a:prstGeom>
-          <a:noFill/>
-        </p:spPr>
-        <p:txBody>
-          <a:bodyPr wrap="square" lIns="45720" rIns="45720">
-            <a:spAutoFit/>
-          </a:bodyPr>
-          <a:lstStyle/>
-          <a:p>
-            <a:pPr algn="l"/>
-            <a:r>
-              <a:rPr sz="1200" b="1">
-                <a:solidFill>
-                  <a:srgbClr val="27AE60"/>
-                </a:solidFill>
-              </a:rPr>
-              <a:t>TAO (Kim 2025, ICML)</a:t>
-            </a:r>
-          </a:p>
-        </p:txBody>
-      </p:sp>
-      <p:sp>
-        <p:nvSpPr>
-          <p:cNvPr id="27" name="TextBox 26"/>
-          <p:cNvSpPr txBox="1"/>
-          <p:nvPr/>
-        </p:nvSpPr>
-        <p:spPr>
-          <a:xfrm>
-            <a:off x="6400800" y="1353312"/>
-            <a:ext cx="5394960" cy="320040"/>
-          </a:xfrm>
-          <a:prstGeom prst="rect">
-            <a:avLst/>
-          </a:prstGeom>
-          <a:noFill/>
-        </p:spPr>
-        <p:txBody>
-          <a:bodyPr wrap="square" lIns="45720" rIns="45720">
-            <a:spAutoFit/>
-          </a:bodyPr>
-          <a:lstStyle/>
-          <a:p>
-            <a:pPr algn="l"/>
-            <a:r>
-              <a:rPr sz="900" b="0">
-                <a:solidFill>
-                  <a:srgbClr val="34495E"/>
-                </a:solidFill>
-              </a:rPr>
-              <a:t>Tiered Agentic Oversight for healthcare safety.</a:t>
-            </a:r>
-          </a:p>
-        </p:txBody>
-      </p:sp>
-      <p:sp>
-        <p:nvSpPr>
-          <p:cNvPr id="28" name="TextBox 27"/>
-          <p:cNvSpPr txBox="1"/>
-          <p:nvPr/>
-        </p:nvSpPr>
-        <p:spPr>
-          <a:xfrm>
-            <a:off x="6400800" y="1645920"/>
-            <a:ext cx="5394960" cy="320040"/>
-          </a:xfrm>
-          <a:prstGeom prst="rect">
-            <a:avLst/>
-          </a:prstGeom>
-          <a:noFill/>
-        </p:spPr>
-        <p:txBody>
-          <a:bodyPr wrap="square" lIns="45720" rIns="45720">
-            <a:spAutoFit/>
-          </a:bodyPr>
-          <a:lstStyle/>
-          <a:p>
-            <a:pPr algn="l"/>
-            <a:r>
-              <a:rPr sz="900" b="1">
-                <a:solidFill>
-                  <a:srgbClr val="34495E"/>
-                </a:solidFill>
-              </a:rPr>
-              <a:t>Result: +8.2% on 4/5 safety benchmarks · triage 40% → 60% w/ MDs.</a:t>
-            </a:r>
-          </a:p>
-        </p:txBody>
-      </p:sp>
-      <p:sp>
-        <p:nvSpPr>
-          <p:cNvPr id="29" name="TextBox 28"/>
-          <p:cNvSpPr txBox="1"/>
-          <p:nvPr/>
-        </p:nvSpPr>
-        <p:spPr>
-          <a:xfrm>
-            <a:off x="6400800" y="1920240"/>
-            <a:ext cx="5394960" cy="320040"/>
-          </a:xfrm>
-          <a:prstGeom prst="rect">
-            <a:avLst/>
-          </a:prstGeom>
-          <a:noFill/>
-        </p:spPr>
-        <p:txBody>
-          <a:bodyPr wrap="square" lIns="45720" rIns="45720">
-            <a:spAutoFit/>
-          </a:bodyPr>
-          <a:lstStyle/>
-          <a:p>
-            <a:pPr algn="l"/>
-            <a:r>
-              <a:rPr sz="900" b="0">
-                <a:solidFill>
-                  <a:srgbClr val="C0392B"/>
-                </a:solidFill>
-              </a:rPr>
-              <a:t>Missing: Safety wrapper, not a diagnostic pipeline · no case-based memory.</a:t>
-            </a:r>
-          </a:p>
-        </p:txBody>
-      </p:sp>
-      <p:sp>
-        <p:nvSpPr>
-          <p:cNvPr id="30" name="Rounded Rectangle 29"/>
-          <p:cNvSpPr/>
-          <p:nvPr/>
-        </p:nvSpPr>
-        <p:spPr>
-          <a:xfrm>
-            <a:off x="6263640" y="2286000"/>
-            <a:ext cx="5623560" cy="1188719"/>
-          </a:xfrm>
-          <a:prstGeom prst="roundRect">
-            <a:avLst/>
-          </a:prstGeom>
-          <a:solidFill>
-            <a:srgbClr val="FFFFFF"/>
-          </a:solidFill>
-          <a:ln w="15875">
-            <a:solidFill>
-              <a:srgbClr val="1F4E79"/>
-            </a:solidFill>
-          </a:ln>
-        </p:spPr>
-        <p:style>
-          <a:lnRef idx="1">
-            <a:schemeClr val="accent1"/>
-          </a:lnRef>
-          <a:fillRef idx="3">
-            <a:schemeClr val="accent1"/>
-          </a:fillRef>
-          <a:effectRef idx="2">
-            <a:schemeClr val="accent1"/>
-          </a:effectRef>
-          <a:fontRef idx="minor">
-            <a:schemeClr val="lt1"/>
-          </a:fontRef>
-        </p:style>
-        <p:txBody>
-          <a:bodyPr rtlCol="0" anchor="ctr"/>
-          <a:lstStyle/>
-          <a:p>
-            <a:pPr algn="ctr"/>
-          </a:p>
-        </p:txBody>
-      </p:sp>
-      <p:sp>
-        <p:nvSpPr>
-          <p:cNvPr id="31" name="TextBox 30"/>
-          <p:cNvSpPr txBox="1"/>
-          <p:nvPr/>
-        </p:nvSpPr>
-        <p:spPr>
-          <a:xfrm>
-            <a:off x="6400800" y="2331720"/>
-            <a:ext cx="5394960" cy="329184"/>
-          </a:xfrm>
-          <a:prstGeom prst="rect">
-            <a:avLst/>
-          </a:prstGeom>
-          <a:noFill/>
-        </p:spPr>
-        <p:txBody>
-          <a:bodyPr wrap="square" lIns="45720" rIns="45720">
-            <a:spAutoFit/>
-          </a:bodyPr>
-          <a:lstStyle/>
-          <a:p>
-            <a:pPr algn="l"/>
-            <a:r>
-              <a:rPr sz="1200" b="1">
-                <a:solidFill>
-                  <a:srgbClr val="1F4E79"/>
-                </a:solidFill>
-              </a:rPr>
-              <a:t>ClinicalLab (Yan 2024)</a:t>
-            </a:r>
-          </a:p>
-        </p:txBody>
-      </p:sp>
-      <p:sp>
-        <p:nvSpPr>
-          <p:cNvPr id="32" name="TextBox 31"/>
-          <p:cNvSpPr txBox="1"/>
-          <p:nvPr/>
-        </p:nvSpPr>
-        <p:spPr>
-          <a:xfrm>
-            <a:off x="6400800" y="2633472"/>
-            <a:ext cx="5394960" cy="320040"/>
-          </a:xfrm>
-          <a:prstGeom prst="rect">
-            <a:avLst/>
-          </a:prstGeom>
-          <a:noFill/>
-        </p:spPr>
-        <p:txBody>
-          <a:bodyPr wrap="square" lIns="45720" rIns="45720">
-            <a:spAutoFit/>
-          </a:bodyPr>
-          <a:lstStyle/>
-          <a:p>
-            <a:pPr algn="l"/>
-            <a:r>
-              <a:rPr sz="900" b="0">
-                <a:solidFill>
-                  <a:srgbClr val="34495E"/>
-                </a:solidFill>
-              </a:rPr>
-              <a:t>Coordinator + Chief Physician across 11 departments.</a:t>
-            </a:r>
-          </a:p>
-        </p:txBody>
-      </p:sp>
-      <p:sp>
-        <p:nvSpPr>
-          <p:cNvPr id="33" name="TextBox 32"/>
-          <p:cNvSpPr txBox="1"/>
-          <p:nvPr/>
-        </p:nvSpPr>
-        <p:spPr>
-          <a:xfrm>
-            <a:off x="6400800" y="2926080"/>
-            <a:ext cx="5394960" cy="320040"/>
-          </a:xfrm>
-          <a:prstGeom prst="rect">
-            <a:avLst/>
-          </a:prstGeom>
-          <a:noFill/>
-        </p:spPr>
-        <p:txBody>
-          <a:bodyPr wrap="square" lIns="45720" rIns="45720">
-            <a:spAutoFit/>
-          </a:bodyPr>
-          <a:lstStyle/>
-          <a:p>
-            <a:pPr algn="l"/>
-            <a:r>
-              <a:rPr sz="900" b="1">
-                <a:solidFill>
-                  <a:srgbClr val="34495E"/>
-                </a:solidFill>
-              </a:rPr>
-              <a:t>Result: Within ~5% of senior physicians on 1,500 real cases.</a:t>
-            </a:r>
-          </a:p>
-        </p:txBody>
-      </p:sp>
-      <p:sp>
-        <p:nvSpPr>
-          <p:cNvPr id="34" name="TextBox 33"/>
-          <p:cNvSpPr txBox="1"/>
-          <p:nvPr/>
-        </p:nvSpPr>
-        <p:spPr>
-          <a:xfrm>
-            <a:off x="6400800" y="3200400"/>
-            <a:ext cx="5394960" cy="320040"/>
-          </a:xfrm>
-          <a:prstGeom prst="rect">
-            <a:avLst/>
-          </a:prstGeom>
-          <a:noFill/>
-        </p:spPr>
-        <p:txBody>
-          <a:bodyPr wrap="square" lIns="45720" rIns="45720">
-            <a:spAutoFit/>
-          </a:bodyPr>
-          <a:lstStyle/>
-          <a:p>
-            <a:pPr algn="l"/>
-            <a:r>
-              <a:rPr sz="900" b="0">
-                <a:solidFill>
-                  <a:srgbClr val="C0392B"/>
-                </a:solidFill>
-              </a:rPr>
-              <a:t>Missing: Closed-source · no published memory subsystem · no doctor UI.</a:t>
-            </a:r>
-          </a:p>
-        </p:txBody>
-      </p:sp>
-      <p:sp>
-        <p:nvSpPr>
-          <p:cNvPr id="35" name="Rounded Rectangle 34"/>
-          <p:cNvSpPr/>
-          <p:nvPr/>
-        </p:nvSpPr>
-        <p:spPr>
-          <a:xfrm>
-            <a:off x="6263640" y="3566160"/>
-            <a:ext cx="5623560" cy="1188719"/>
-          </a:xfrm>
-          <a:prstGeom prst="roundRect">
-            <a:avLst/>
-          </a:prstGeom>
-          <a:solidFill>
-            <a:srgbClr val="FFFFFF"/>
-          </a:solidFill>
-          <a:ln w="15875">
-            <a:solidFill>
-              <a:srgbClr val="16A085"/>
-            </a:solidFill>
-          </a:ln>
-        </p:spPr>
-        <p:style>
-          <a:lnRef idx="1">
-            <a:schemeClr val="accent1"/>
-          </a:lnRef>
-          <a:fillRef idx="3">
-            <a:schemeClr val="accent1"/>
-          </a:fillRef>
-          <a:effectRef idx="2">
-            <a:schemeClr val="accent1"/>
-          </a:effectRef>
-          <a:fontRef idx="minor">
-            <a:schemeClr val="lt1"/>
-          </a:fontRef>
-        </p:style>
-        <p:txBody>
-          <a:bodyPr rtlCol="0" anchor="ctr"/>
-          <a:lstStyle/>
-          <a:p>
-            <a:pPr algn="ctr"/>
-          </a:p>
-        </p:txBody>
-      </p:sp>
-      <p:sp>
-        <p:nvSpPr>
-          <p:cNvPr id="36" name="TextBox 35"/>
-          <p:cNvSpPr txBox="1"/>
-          <p:nvPr/>
-        </p:nvSpPr>
-        <p:spPr>
-          <a:xfrm>
-            <a:off x="6400800" y="3611879"/>
-            <a:ext cx="5394960" cy="329184"/>
-          </a:xfrm>
-          <a:prstGeom prst="rect">
-            <a:avLst/>
-          </a:prstGeom>
-          <a:noFill/>
-        </p:spPr>
-        <p:txBody>
-          <a:bodyPr wrap="square" lIns="45720" rIns="45720">
-            <a:spAutoFit/>
-          </a:bodyPr>
-          <a:lstStyle/>
-          <a:p>
-            <a:pPr algn="l"/>
-            <a:r>
-              <a:rPr sz="1200" b="1">
-                <a:solidFill>
-                  <a:srgbClr val="16A085"/>
-                </a:solidFill>
-              </a:rPr>
-              <a:t>ZODIAC (Zhou 2024)</a:t>
-            </a:r>
-          </a:p>
-        </p:txBody>
-      </p:sp>
-      <p:sp>
-        <p:nvSpPr>
-          <p:cNvPr id="37" name="TextBox 36"/>
-          <p:cNvSpPr txBox="1"/>
-          <p:nvPr/>
-        </p:nvSpPr>
-        <p:spPr>
-          <a:xfrm>
-            <a:off x="6400800" y="3913632"/>
-            <a:ext cx="5394960" cy="320040"/>
-          </a:xfrm>
-          <a:prstGeom prst="rect">
-            <a:avLst/>
-          </a:prstGeom>
-          <a:noFill/>
-        </p:spPr>
-        <p:txBody>
-          <a:bodyPr wrap="square" lIns="45720" rIns="45720">
-            <a:spAutoFit/>
-          </a:bodyPr>
-          <a:lstStyle/>
-          <a:p>
-            <a:pPr algn="l"/>
-            <a:r>
-              <a:rPr sz="900" b="0">
-                <a:solidFill>
-                  <a:srgbClr val="34495E"/>
-                </a:solidFill>
-              </a:rPr>
-              <a:t>5-agent cardiology + clinician review.</a:t>
-            </a:r>
-          </a:p>
-        </p:txBody>
-      </p:sp>
-      <p:sp>
-        <p:nvSpPr>
-          <p:cNvPr id="38" name="TextBox 37"/>
-          <p:cNvSpPr txBox="1"/>
-          <p:nvPr/>
-        </p:nvSpPr>
-        <p:spPr>
-          <a:xfrm>
-            <a:off x="6400800" y="4206240"/>
-            <a:ext cx="5394960" cy="320040"/>
-          </a:xfrm>
-          <a:prstGeom prst="rect">
-            <a:avLst/>
-          </a:prstGeom>
-          <a:noFill/>
-        </p:spPr>
-        <p:txBody>
-          <a:bodyPr wrap="square" lIns="45720" rIns="45720">
-            <a:spAutoFit/>
-          </a:bodyPr>
-          <a:lstStyle/>
-          <a:p>
-            <a:pPr algn="l"/>
-            <a:r>
-              <a:rPr sz="900" b="1">
-                <a:solidFill>
-                  <a:srgbClr val="34495E"/>
-                </a:solidFill>
-              </a:rPr>
-              <a:t>Result: Cardiologist-level on 7/8 metrics (qualitative).</a:t>
-            </a:r>
-          </a:p>
-        </p:txBody>
-      </p:sp>
-      <p:sp>
-        <p:nvSpPr>
-          <p:cNvPr id="39" name="TextBox 38"/>
-          <p:cNvSpPr txBox="1"/>
-          <p:nvPr/>
-        </p:nvSpPr>
-        <p:spPr>
-          <a:xfrm>
-            <a:off x="6400800" y="4480560"/>
-            <a:ext cx="5394960" cy="320040"/>
-          </a:xfrm>
-          <a:prstGeom prst="rect">
-            <a:avLst/>
-          </a:prstGeom>
-          <a:noFill/>
-        </p:spPr>
-        <p:txBody>
-          <a:bodyPr wrap="square" lIns="45720" rIns="45720">
-            <a:spAutoFit/>
-          </a:bodyPr>
-          <a:lstStyle/>
-          <a:p>
-            <a:pPr algn="l"/>
-            <a:r>
-              <a:rPr sz="900" b="0">
-                <a:solidFill>
-                  <a:srgbClr val="C0392B"/>
-                </a:solidFill>
-              </a:rPr>
-              <a:t>Missing: Single specialty · no memory · no treatment plan · no open backbone.</a:t>
-            </a:r>
-          </a:p>
-        </p:txBody>
-      </p:sp>
-      <p:sp>
-        <p:nvSpPr>
-          <p:cNvPr id="40" name="TextBox 39"/>
-          <p:cNvSpPr txBox="1"/>
-          <p:nvPr/>
-        </p:nvSpPr>
-        <p:spPr>
-          <a:xfrm>
-            <a:off x="320040" y="6263640"/>
-            <a:ext cx="11521440" cy="365760"/>
-          </a:xfrm>
-          <a:prstGeom prst="rect">
-            <a:avLst/>
-          </a:prstGeom>
-          <a:noFill/>
-        </p:spPr>
-        <p:txBody>
-          <a:bodyPr wrap="square" lIns="45720" rIns="45720">
-            <a:spAutoFit/>
-          </a:bodyPr>
-          <a:lstStyle/>
-          <a:p>
-            <a:pPr algn="ctr"/>
             <a:r>
               <a:rPr sz="1000" b="0">
                 <a:solidFill>
                   <a:srgbClr val="7F8C8D"/>
                 </a:solidFill>
               </a:rPr>
-              <a:t>Comparison is on multiple axes: cohort + headline + what each system leaves out. CMADS fills the union of those gaps.</a:t>
+              <a:t>URL-driven state: ?r=&lt;set&gt;&amp;p=&lt;uuid&gt;&amp;a=&lt;agent&gt; makes every view shareable and refresh-safe.</a:t>
             </a:r>
           </a:p>
         </p:txBody>
@@ -7774,6 +7549,1455 @@
 </file>
 
 <file path=ppt/slides/slide6.xml><?xml version="1.0" encoding="utf-8"?>
+<p:sld xmlns:a="http://schemas.openxmlformats.org/drawingml/2006/main" xmlns:p="http://schemas.openxmlformats.org/presentationml/2006/main" xmlns:r="http://schemas.openxmlformats.org/officeDocument/2006/relationships">
+  <p:cSld>
+    <p:spTree>
+      <p:nvGrpSpPr>
+        <p:cNvPr id="1" name=""/>
+        <p:cNvGrpSpPr/>
+        <p:nvPr/>
+      </p:nvGrpSpPr>
+      <p:grpSpPr/>
+      <p:sp>
+        <p:nvSpPr>
+          <p:cNvPr id="2" name="Rectangle 1"/>
+          <p:cNvSpPr/>
+          <p:nvPr/>
+        </p:nvSpPr>
+        <p:spPr>
+          <a:xfrm>
+            <a:off x="0" y="0"/>
+            <a:ext cx="12191695" cy="6858000"/>
+          </a:xfrm>
+          <a:prstGeom prst="rect">
+            <a:avLst/>
+          </a:prstGeom>
+          <a:solidFill>
+            <a:srgbClr val="F7F9FC"/>
+          </a:solidFill>
+          <a:ln>
+            <a:noFill/>
+          </a:ln>
+          <a:effectLst/>
+        </p:spPr>
+        <p:style>
+          <a:lnRef idx="1">
+            <a:schemeClr val="accent1"/>
+          </a:lnRef>
+          <a:fillRef idx="3">
+            <a:schemeClr val="accent1"/>
+          </a:fillRef>
+          <a:effectRef idx="2">
+            <a:schemeClr val="accent1"/>
+          </a:effectRef>
+          <a:fontRef idx="minor">
+            <a:schemeClr val="lt1"/>
+          </a:fontRef>
+        </p:style>
+        <p:txBody>
+          <a:bodyPr rtlCol="0" anchor="ctr"/>
+          <a:lstStyle/>
+          <a:p>
+            <a:pPr algn="ctr"/>
+          </a:p>
+        </p:txBody>
+      </p:sp>
+      <p:sp>
+        <p:nvSpPr>
+          <p:cNvPr id="3" name="Rectangle 2"/>
+          <p:cNvSpPr/>
+          <p:nvPr/>
+        </p:nvSpPr>
+        <p:spPr>
+          <a:xfrm>
+            <a:off x="0" y="0"/>
+            <a:ext cx="12191695" cy="868680"/>
+          </a:xfrm>
+          <a:prstGeom prst="rect">
+            <a:avLst/>
+          </a:prstGeom>
+          <a:solidFill>
+            <a:srgbClr val="142B4A"/>
+          </a:solidFill>
+          <a:ln>
+            <a:noFill/>
+          </a:ln>
+        </p:spPr>
+        <p:style>
+          <a:lnRef idx="1">
+            <a:schemeClr val="accent1"/>
+          </a:lnRef>
+          <a:fillRef idx="3">
+            <a:schemeClr val="accent1"/>
+          </a:fillRef>
+          <a:effectRef idx="2">
+            <a:schemeClr val="accent1"/>
+          </a:effectRef>
+          <a:fontRef idx="minor">
+            <a:schemeClr val="lt1"/>
+          </a:fontRef>
+        </p:style>
+        <p:txBody>
+          <a:bodyPr rtlCol="0" anchor="ctr"/>
+          <a:lstStyle/>
+          <a:p>
+            <a:pPr algn="ctr"/>
+          </a:p>
+        </p:txBody>
+      </p:sp>
+      <p:sp>
+        <p:nvSpPr>
+          <p:cNvPr id="4" name="TextBox 3"/>
+          <p:cNvSpPr txBox="1"/>
+          <p:nvPr/>
+        </p:nvSpPr>
+        <p:spPr>
+          <a:xfrm>
+            <a:off x="411480" y="164592"/>
+            <a:ext cx="11338560" cy="640080"/>
+          </a:xfrm>
+          <a:prstGeom prst="rect">
+            <a:avLst/>
+          </a:prstGeom>
+          <a:noFill/>
+        </p:spPr>
+        <p:txBody>
+          <a:bodyPr wrap="none" lIns="0" rIns="0">
+            <a:spAutoFit/>
+          </a:bodyPr>
+          <a:lstStyle/>
+          <a:p>
+            <a:r>
+              <a:rPr sz="2600" b="1">
+                <a:solidFill>
+                  <a:srgbClr val="FFFFFF"/>
+                </a:solidFill>
+              </a:rPr>
+              <a:t>Where CMADS sits against the literature</a:t>
+            </a:r>
+          </a:p>
+          <a:p>
+            <a:r>
+              <a:rPr sz="1300">
+                <a:solidFill>
+                  <a:srgbClr val="ECF0F1"/>
+                </a:solidFill>
+              </a:rPr>
+              <a:t>Seven comparators · what they do, their result, and what they leave out</a:t>
+            </a:r>
+          </a:p>
+        </p:txBody>
+      </p:sp>
+      <p:sp>
+        <p:nvSpPr>
+          <p:cNvPr id="5" name="Rounded Rectangle 4"/>
+          <p:cNvSpPr/>
+          <p:nvPr/>
+        </p:nvSpPr>
+        <p:spPr>
+          <a:xfrm>
+            <a:off x="320040" y="1005840"/>
+            <a:ext cx="5623560" cy="1188719"/>
+          </a:xfrm>
+          <a:prstGeom prst="roundRect">
+            <a:avLst/>
+          </a:prstGeom>
+          <a:solidFill>
+            <a:srgbClr val="FFFFFF"/>
+          </a:solidFill>
+          <a:ln w="15875">
+            <a:solidFill>
+              <a:srgbClr val="1F4E79"/>
+            </a:solidFill>
+          </a:ln>
+        </p:spPr>
+        <p:style>
+          <a:lnRef idx="1">
+            <a:schemeClr val="accent1"/>
+          </a:lnRef>
+          <a:fillRef idx="3">
+            <a:schemeClr val="accent1"/>
+          </a:fillRef>
+          <a:effectRef idx="2">
+            <a:schemeClr val="accent1"/>
+          </a:effectRef>
+          <a:fontRef idx="minor">
+            <a:schemeClr val="lt1"/>
+          </a:fontRef>
+        </p:style>
+        <p:txBody>
+          <a:bodyPr rtlCol="0" anchor="ctr"/>
+          <a:lstStyle/>
+          <a:p>
+            <a:pPr algn="ctr"/>
+          </a:p>
+        </p:txBody>
+      </p:sp>
+      <p:sp>
+        <p:nvSpPr>
+          <p:cNvPr id="6" name="TextBox 5"/>
+          <p:cNvSpPr txBox="1"/>
+          <p:nvPr/>
+        </p:nvSpPr>
+        <p:spPr>
+          <a:xfrm>
+            <a:off x="457200" y="1051560"/>
+            <a:ext cx="5394960" cy="329184"/>
+          </a:xfrm>
+          <a:prstGeom prst="rect">
+            <a:avLst/>
+          </a:prstGeom>
+          <a:noFill/>
+        </p:spPr>
+        <p:txBody>
+          <a:bodyPr wrap="square" lIns="45720" rIns="45720">
+            <a:spAutoFit/>
+          </a:bodyPr>
+          <a:lstStyle/>
+          <a:p>
+            <a:pPr algn="l"/>
+            <a:r>
+              <a:rPr sz="1200" b="1">
+                <a:solidFill>
+                  <a:srgbClr val="1F4E79"/>
+                </a:solidFill>
+              </a:rPr>
+              <a:t>AMIE (Tu 2024)</a:t>
+            </a:r>
+          </a:p>
+        </p:txBody>
+      </p:sp>
+      <p:sp>
+        <p:nvSpPr>
+          <p:cNvPr id="7" name="TextBox 6"/>
+          <p:cNvSpPr txBox="1"/>
+          <p:nvPr/>
+        </p:nvSpPr>
+        <p:spPr>
+          <a:xfrm>
+            <a:off x="457200" y="1353312"/>
+            <a:ext cx="5394960" cy="320040"/>
+          </a:xfrm>
+          <a:prstGeom prst="rect">
+            <a:avLst/>
+          </a:prstGeom>
+          <a:noFill/>
+        </p:spPr>
+        <p:txBody>
+          <a:bodyPr wrap="square" lIns="45720" rIns="45720">
+            <a:spAutoFit/>
+          </a:bodyPr>
+          <a:lstStyle/>
+          <a:p>
+            <a:pPr algn="l"/>
+            <a:r>
+              <a:rPr sz="900" b="0">
+                <a:solidFill>
+                  <a:srgbClr val="34495E"/>
+                </a:solidFill>
+              </a:rPr>
+              <a:t>Conversational diagnostic AI; OSCE-style consultations.</a:t>
+            </a:r>
+          </a:p>
+        </p:txBody>
+      </p:sp>
+      <p:sp>
+        <p:nvSpPr>
+          <p:cNvPr id="8" name="TextBox 7"/>
+          <p:cNvSpPr txBox="1"/>
+          <p:nvPr/>
+        </p:nvSpPr>
+        <p:spPr>
+          <a:xfrm>
+            <a:off x="457200" y="1645920"/>
+            <a:ext cx="5394960" cy="320040"/>
+          </a:xfrm>
+          <a:prstGeom prst="rect">
+            <a:avLst/>
+          </a:prstGeom>
+          <a:noFill/>
+        </p:spPr>
+        <p:txBody>
+          <a:bodyPr wrap="square" lIns="45720" rIns="45720">
+            <a:spAutoFit/>
+          </a:bodyPr>
+          <a:lstStyle/>
+          <a:p>
+            <a:pPr algn="l"/>
+            <a:r>
+              <a:rPr sz="900" b="1">
+                <a:solidFill>
+                  <a:srgbClr val="34495E"/>
+                </a:solidFill>
+              </a:rPr>
+              <a:t>Result: Beat PCPs on 28/32 specialist axes (149 cases · 20 PCPs).</a:t>
+            </a:r>
+          </a:p>
+        </p:txBody>
+      </p:sp>
+      <p:sp>
+        <p:nvSpPr>
+          <p:cNvPr id="9" name="TextBox 8"/>
+          <p:cNvSpPr txBox="1"/>
+          <p:nvPr/>
+        </p:nvSpPr>
+        <p:spPr>
+          <a:xfrm>
+            <a:off x="457200" y="1920240"/>
+            <a:ext cx="5394960" cy="320040"/>
+          </a:xfrm>
+          <a:prstGeom prst="rect">
+            <a:avLst/>
+          </a:prstGeom>
+          <a:noFill/>
+        </p:spPr>
+        <p:txBody>
+          <a:bodyPr wrap="square" lIns="45720" rIns="45720">
+            <a:spAutoFit/>
+          </a:bodyPr>
+          <a:lstStyle/>
+          <a:p>
+            <a:pPr algn="l"/>
+            <a:r>
+              <a:rPr sz="900" b="0">
+                <a:solidFill>
+                  <a:srgbClr val="C0392B"/>
+                </a:solidFill>
+              </a:rPr>
+              <a:t>Missing: Closed-source backbone · no doctor UI · no inspectable memory.</a:t>
+            </a:r>
+          </a:p>
+        </p:txBody>
+      </p:sp>
+      <p:sp>
+        <p:nvSpPr>
+          <p:cNvPr id="10" name="Rounded Rectangle 9"/>
+          <p:cNvSpPr/>
+          <p:nvPr/>
+        </p:nvSpPr>
+        <p:spPr>
+          <a:xfrm>
+            <a:off x="320040" y="2286000"/>
+            <a:ext cx="5623560" cy="1188719"/>
+          </a:xfrm>
+          <a:prstGeom prst="roundRect">
+            <a:avLst/>
+          </a:prstGeom>
+          <a:solidFill>
+            <a:srgbClr val="FFFFFF"/>
+          </a:solidFill>
+          <a:ln w="15875">
+            <a:solidFill>
+              <a:srgbClr val="16A085"/>
+            </a:solidFill>
+          </a:ln>
+        </p:spPr>
+        <p:style>
+          <a:lnRef idx="1">
+            <a:schemeClr val="accent1"/>
+          </a:lnRef>
+          <a:fillRef idx="3">
+            <a:schemeClr val="accent1"/>
+          </a:fillRef>
+          <a:effectRef idx="2">
+            <a:schemeClr val="accent1"/>
+          </a:effectRef>
+          <a:fontRef idx="minor">
+            <a:schemeClr val="lt1"/>
+          </a:fontRef>
+        </p:style>
+        <p:txBody>
+          <a:bodyPr rtlCol="0" anchor="ctr"/>
+          <a:lstStyle/>
+          <a:p>
+            <a:pPr algn="ctr"/>
+          </a:p>
+        </p:txBody>
+      </p:sp>
+      <p:sp>
+        <p:nvSpPr>
+          <p:cNvPr id="11" name="TextBox 10"/>
+          <p:cNvSpPr txBox="1"/>
+          <p:nvPr/>
+        </p:nvSpPr>
+        <p:spPr>
+          <a:xfrm>
+            <a:off x="457200" y="2331720"/>
+            <a:ext cx="5394960" cy="329184"/>
+          </a:xfrm>
+          <a:prstGeom prst="rect">
+            <a:avLst/>
+          </a:prstGeom>
+          <a:noFill/>
+        </p:spPr>
+        <p:txBody>
+          <a:bodyPr wrap="square" lIns="45720" rIns="45720">
+            <a:spAutoFit/>
+          </a:bodyPr>
+          <a:lstStyle/>
+          <a:p>
+            <a:pPr algn="l"/>
+            <a:r>
+              <a:rPr sz="1200" b="1">
+                <a:solidFill>
+                  <a:srgbClr val="16A085"/>
+                </a:solidFill>
+              </a:rPr>
+              <a:t>AgentClinic (Schmidgall 2024)</a:t>
+            </a:r>
+          </a:p>
+        </p:txBody>
+      </p:sp>
+      <p:sp>
+        <p:nvSpPr>
+          <p:cNvPr id="12" name="TextBox 11"/>
+          <p:cNvSpPr txBox="1"/>
+          <p:nvPr/>
+        </p:nvSpPr>
+        <p:spPr>
+          <a:xfrm>
+            <a:off x="457200" y="2633472"/>
+            <a:ext cx="5394960" cy="320040"/>
+          </a:xfrm>
+          <a:prstGeom prst="rect">
+            <a:avLst/>
+          </a:prstGeom>
+          <a:noFill/>
+        </p:spPr>
+        <p:txBody>
+          <a:bodyPr wrap="square" lIns="45720" rIns="45720">
+            <a:spAutoFit/>
+          </a:bodyPr>
+          <a:lstStyle/>
+          <a:p>
+            <a:pPr algn="l"/>
+            <a:r>
+              <a:rPr sz="900" b="0">
+                <a:solidFill>
+                  <a:srgbClr val="34495E"/>
+                </a:solidFill>
+              </a:rPr>
+              <a:t>Multimodal benchmark of LLM agents in simulated clinics.</a:t>
+            </a:r>
+          </a:p>
+        </p:txBody>
+      </p:sp>
+      <p:sp>
+        <p:nvSpPr>
+          <p:cNvPr id="13" name="TextBox 12"/>
+          <p:cNvSpPr txBox="1"/>
+          <p:nvPr/>
+        </p:nvSpPr>
+        <p:spPr>
+          <a:xfrm>
+            <a:off x="457200" y="2926080"/>
+            <a:ext cx="5394960" cy="320040"/>
+          </a:xfrm>
+          <a:prstGeom prst="rect">
+            <a:avLst/>
+          </a:prstGeom>
+          <a:noFill/>
+        </p:spPr>
+        <p:txBody>
+          <a:bodyPr wrap="square" lIns="45720" rIns="45720">
+            <a:spAutoFit/>
+          </a:bodyPr>
+          <a:lstStyle/>
+          <a:p>
+            <a:pPr algn="l"/>
+            <a:r>
+              <a:rPr sz="900" b="1">
+                <a:solidFill>
+                  <a:srgbClr val="34495E"/>
+                </a:solidFill>
+              </a:rPr>
+              <a:t>Result: Claude-3.5: 62.1% on AgentClinic-MedQA · PCPs 54%±28.5.</a:t>
+            </a:r>
+          </a:p>
+        </p:txBody>
+      </p:sp>
+      <p:sp>
+        <p:nvSpPr>
+          <p:cNvPr id="14" name="TextBox 13"/>
+          <p:cNvSpPr txBox="1"/>
+          <p:nvPr/>
+        </p:nvSpPr>
+        <p:spPr>
+          <a:xfrm>
+            <a:off x="457200" y="3200400"/>
+            <a:ext cx="5394960" cy="320040"/>
+          </a:xfrm>
+          <a:prstGeom prst="rect">
+            <a:avLst/>
+          </a:prstGeom>
+          <a:noFill/>
+        </p:spPr>
+        <p:txBody>
+          <a:bodyPr wrap="square" lIns="45720" rIns="45720">
+            <a:spAutoFit/>
+          </a:bodyPr>
+          <a:lstStyle/>
+          <a:p>
+            <a:pPr algn="l"/>
+            <a:r>
+              <a:rPr sz="900" b="0">
+                <a:solidFill>
+                  <a:srgbClr val="C0392B"/>
+                </a:solidFill>
+              </a:rPr>
+              <a:t>Missing: Benchmark of others, not a deployed pipeline · no treatment plan.</a:t>
+            </a:r>
+          </a:p>
+        </p:txBody>
+      </p:sp>
+      <p:sp>
+        <p:nvSpPr>
+          <p:cNvPr id="15" name="Rounded Rectangle 14"/>
+          <p:cNvSpPr/>
+          <p:nvPr/>
+        </p:nvSpPr>
+        <p:spPr>
+          <a:xfrm>
+            <a:off x="320040" y="3566160"/>
+            <a:ext cx="5623560" cy="1188719"/>
+          </a:xfrm>
+          <a:prstGeom prst="roundRect">
+            <a:avLst/>
+          </a:prstGeom>
+          <a:solidFill>
+            <a:srgbClr val="FFFFFF"/>
+          </a:solidFill>
+          <a:ln w="15875">
+            <a:solidFill>
+              <a:srgbClr val="142B4A"/>
+            </a:solidFill>
+          </a:ln>
+        </p:spPr>
+        <p:style>
+          <a:lnRef idx="1">
+            <a:schemeClr val="accent1"/>
+          </a:lnRef>
+          <a:fillRef idx="3">
+            <a:schemeClr val="accent1"/>
+          </a:fillRef>
+          <a:effectRef idx="2">
+            <a:schemeClr val="accent1"/>
+          </a:effectRef>
+          <a:fontRef idx="minor">
+            <a:schemeClr val="lt1"/>
+          </a:fontRef>
+        </p:style>
+        <p:txBody>
+          <a:bodyPr rtlCol="0" anchor="ctr"/>
+          <a:lstStyle/>
+          <a:p>
+            <a:pPr algn="ctr"/>
+          </a:p>
+        </p:txBody>
+      </p:sp>
+      <p:sp>
+        <p:nvSpPr>
+          <p:cNvPr id="16" name="TextBox 15"/>
+          <p:cNvSpPr txBox="1"/>
+          <p:nvPr/>
+        </p:nvSpPr>
+        <p:spPr>
+          <a:xfrm>
+            <a:off x="457200" y="3611879"/>
+            <a:ext cx="5394960" cy="329184"/>
+          </a:xfrm>
+          <a:prstGeom prst="rect">
+            <a:avLst/>
+          </a:prstGeom>
+          <a:noFill/>
+        </p:spPr>
+        <p:txBody>
+          <a:bodyPr wrap="square" lIns="45720" rIns="45720">
+            <a:spAutoFit/>
+          </a:bodyPr>
+          <a:lstStyle/>
+          <a:p>
+            <a:pPr algn="l"/>
+            <a:r>
+              <a:rPr sz="1200" b="1">
+                <a:solidFill>
+                  <a:srgbClr val="142B4A"/>
+                </a:solidFill>
+              </a:rPr>
+              <a:t>MedAgents (Tang 2024, ACL)</a:t>
+            </a:r>
+          </a:p>
+        </p:txBody>
+      </p:sp>
+      <p:sp>
+        <p:nvSpPr>
+          <p:cNvPr id="17" name="TextBox 16"/>
+          <p:cNvSpPr txBox="1"/>
+          <p:nvPr/>
+        </p:nvSpPr>
+        <p:spPr>
+          <a:xfrm>
+            <a:off x="457200" y="3913632"/>
+            <a:ext cx="5394960" cy="320040"/>
+          </a:xfrm>
+          <a:prstGeom prst="rect">
+            <a:avLst/>
+          </a:prstGeom>
+          <a:noFill/>
+        </p:spPr>
+        <p:txBody>
+          <a:bodyPr wrap="square" lIns="45720" rIns="45720">
+            <a:spAutoFit/>
+          </a:bodyPr>
+          <a:lstStyle/>
+          <a:p>
+            <a:pPr algn="l"/>
+            <a:r>
+              <a:rPr sz="900" b="0">
+                <a:solidFill>
+                  <a:srgbClr val="34495E"/>
+                </a:solidFill>
+              </a:rPr>
+              <a:t>Multi-agent CoT for zero-shot medical reasoning.</a:t>
+            </a:r>
+          </a:p>
+        </p:txBody>
+      </p:sp>
+      <p:sp>
+        <p:nvSpPr>
+          <p:cNvPr id="18" name="TextBox 17"/>
+          <p:cNvSpPr txBox="1"/>
+          <p:nvPr/>
+        </p:nvSpPr>
+        <p:spPr>
+          <a:xfrm>
+            <a:off x="457200" y="4206240"/>
+            <a:ext cx="5394960" cy="320040"/>
+          </a:xfrm>
+          <a:prstGeom prst="rect">
+            <a:avLst/>
+          </a:prstGeom>
+          <a:noFill/>
+        </p:spPr>
+        <p:txBody>
+          <a:bodyPr wrap="square" lIns="45720" rIns="45720">
+            <a:spAutoFit/>
+          </a:bodyPr>
+          <a:lstStyle/>
+          <a:p>
+            <a:pPr algn="l"/>
+            <a:r>
+              <a:rPr sz="900" b="1">
+                <a:solidFill>
+                  <a:srgbClr val="34495E"/>
+                </a:solidFill>
+              </a:rPr>
+              <a:t>Result: GPT-4: 86.7% avg on 9 MCQ benchmarks (MedQA 83.7%).</a:t>
+            </a:r>
+          </a:p>
+        </p:txBody>
+      </p:sp>
+      <p:sp>
+        <p:nvSpPr>
+          <p:cNvPr id="19" name="TextBox 18"/>
+          <p:cNvSpPr txBox="1"/>
+          <p:nvPr/>
+        </p:nvSpPr>
+        <p:spPr>
+          <a:xfrm>
+            <a:off x="457200" y="4480560"/>
+            <a:ext cx="5394960" cy="320040"/>
+          </a:xfrm>
+          <a:prstGeom prst="rect">
+            <a:avLst/>
+          </a:prstGeom>
+          <a:noFill/>
+        </p:spPr>
+        <p:txBody>
+          <a:bodyPr wrap="square" lIns="45720" rIns="45720">
+            <a:spAutoFit/>
+          </a:bodyPr>
+          <a:lstStyle/>
+          <a:p>
+            <a:pPr algn="l"/>
+            <a:r>
+              <a:rPr sz="900" b="0">
+                <a:solidFill>
+                  <a:srgbClr val="C0392B"/>
+                </a:solidFill>
+              </a:rPr>
+              <a:t>Missing: MCQ-only · no patient data · no memory · no UI.</a:t>
+            </a:r>
+          </a:p>
+        </p:txBody>
+      </p:sp>
+      <p:sp>
+        <p:nvSpPr>
+          <p:cNvPr id="20" name="Rounded Rectangle 19"/>
+          <p:cNvSpPr/>
+          <p:nvPr/>
+        </p:nvSpPr>
+        <p:spPr>
+          <a:xfrm>
+            <a:off x="320040" y="4846319"/>
+            <a:ext cx="5623560" cy="1188719"/>
+          </a:xfrm>
+          <a:prstGeom prst="roundRect">
+            <a:avLst/>
+          </a:prstGeom>
+          <a:solidFill>
+            <a:srgbClr val="FFFFFF"/>
+          </a:solidFill>
+          <a:ln w="15875">
+            <a:solidFill>
+              <a:srgbClr val="D35400"/>
+            </a:solidFill>
+          </a:ln>
+        </p:spPr>
+        <p:style>
+          <a:lnRef idx="1">
+            <a:schemeClr val="accent1"/>
+          </a:lnRef>
+          <a:fillRef idx="3">
+            <a:schemeClr val="accent1"/>
+          </a:fillRef>
+          <a:effectRef idx="2">
+            <a:schemeClr val="accent1"/>
+          </a:effectRef>
+          <a:fontRef idx="minor">
+            <a:schemeClr val="lt1"/>
+          </a:fontRef>
+        </p:style>
+        <p:txBody>
+          <a:bodyPr rtlCol="0" anchor="ctr"/>
+          <a:lstStyle/>
+          <a:p>
+            <a:pPr algn="ctr"/>
+          </a:p>
+        </p:txBody>
+      </p:sp>
+      <p:sp>
+        <p:nvSpPr>
+          <p:cNvPr id="21" name="TextBox 20"/>
+          <p:cNvSpPr txBox="1"/>
+          <p:nvPr/>
+        </p:nvSpPr>
+        <p:spPr>
+          <a:xfrm>
+            <a:off x="457200" y="4892039"/>
+            <a:ext cx="5394960" cy="329184"/>
+          </a:xfrm>
+          <a:prstGeom prst="rect">
+            <a:avLst/>
+          </a:prstGeom>
+          <a:noFill/>
+        </p:spPr>
+        <p:txBody>
+          <a:bodyPr wrap="square" lIns="45720" rIns="45720">
+            <a:spAutoFit/>
+          </a:bodyPr>
+          <a:lstStyle/>
+          <a:p>
+            <a:pPr algn="l"/>
+            <a:r>
+              <a:rPr sz="1200" b="1">
+                <a:solidFill>
+                  <a:srgbClr val="D35400"/>
+                </a:solidFill>
+              </a:rPr>
+              <a:t>MDTeamGPT (Chen 2025)</a:t>
+            </a:r>
+          </a:p>
+        </p:txBody>
+      </p:sp>
+      <p:sp>
+        <p:nvSpPr>
+          <p:cNvPr id="22" name="TextBox 21"/>
+          <p:cNvSpPr txBox="1"/>
+          <p:nvPr/>
+        </p:nvSpPr>
+        <p:spPr>
+          <a:xfrm>
+            <a:off x="457200" y="5193791"/>
+            <a:ext cx="5394960" cy="320040"/>
+          </a:xfrm>
+          <a:prstGeom prst="rect">
+            <a:avLst/>
+          </a:prstGeom>
+          <a:noFill/>
+        </p:spPr>
+        <p:txBody>
+          <a:bodyPr wrap="square" lIns="45720" rIns="45720">
+            <a:spAutoFit/>
+          </a:bodyPr>
+          <a:lstStyle/>
+          <a:p>
+            <a:pPr algn="l"/>
+            <a:r>
+              <a:rPr sz="900" b="0">
+                <a:solidFill>
+                  <a:srgbClr val="34495E"/>
+                </a:solidFill>
+              </a:rPr>
+              <a:t>Self-evolving MDT with CorrectKB + ChainKB.</a:t>
+            </a:r>
+          </a:p>
+        </p:txBody>
+      </p:sp>
+      <p:sp>
+        <p:nvSpPr>
+          <p:cNvPr id="23" name="TextBox 22"/>
+          <p:cNvSpPr txBox="1"/>
+          <p:nvPr/>
+        </p:nvSpPr>
+        <p:spPr>
+          <a:xfrm>
+            <a:off x="457200" y="5486399"/>
+            <a:ext cx="5394960" cy="320040"/>
+          </a:xfrm>
+          <a:prstGeom prst="rect">
+            <a:avLst/>
+          </a:prstGeom>
+          <a:noFill/>
+        </p:spPr>
+        <p:txBody>
+          <a:bodyPr wrap="square" lIns="45720" rIns="45720">
+            <a:spAutoFit/>
+          </a:bodyPr>
+          <a:lstStyle/>
+          <a:p>
+            <a:pPr algn="l"/>
+            <a:r>
+              <a:rPr sz="900" b="1">
+                <a:solidFill>
+                  <a:srgbClr val="34495E"/>
+                </a:solidFill>
+              </a:rPr>
+              <a:t>Result: 90.1% on MedQA · 83.9% on PubMedQA.</a:t>
+            </a:r>
+          </a:p>
+        </p:txBody>
+      </p:sp>
+      <p:sp>
+        <p:nvSpPr>
+          <p:cNvPr id="24" name="TextBox 23"/>
+          <p:cNvSpPr txBox="1"/>
+          <p:nvPr/>
+        </p:nvSpPr>
+        <p:spPr>
+          <a:xfrm>
+            <a:off x="457200" y="5760719"/>
+            <a:ext cx="5394960" cy="320040"/>
+          </a:xfrm>
+          <a:prstGeom prst="rect">
+            <a:avLst/>
+          </a:prstGeom>
+          <a:noFill/>
+        </p:spPr>
+        <p:txBody>
+          <a:bodyPr wrap="square" lIns="45720" rIns="45720">
+            <a:spAutoFit/>
+          </a:bodyPr>
+          <a:lstStyle/>
+          <a:p>
+            <a:pPr algn="l"/>
+            <a:r>
+              <a:rPr sz="900" b="0">
+                <a:solidFill>
+                  <a:srgbClr val="C0392B"/>
+                </a:solidFill>
+              </a:rPr>
+              <a:t>Missing: MCQ-only · no end-to-end pipeline · no clinician interface.</a:t>
+            </a:r>
+          </a:p>
+        </p:txBody>
+      </p:sp>
+      <p:sp>
+        <p:nvSpPr>
+          <p:cNvPr id="25" name="Rounded Rectangle 24"/>
+          <p:cNvSpPr/>
+          <p:nvPr/>
+        </p:nvSpPr>
+        <p:spPr>
+          <a:xfrm>
+            <a:off x="6263640" y="1005840"/>
+            <a:ext cx="5623560" cy="1188719"/>
+          </a:xfrm>
+          <a:prstGeom prst="roundRect">
+            <a:avLst/>
+          </a:prstGeom>
+          <a:solidFill>
+            <a:srgbClr val="FFFFFF"/>
+          </a:solidFill>
+          <a:ln w="15875">
+            <a:solidFill>
+              <a:srgbClr val="27AE60"/>
+            </a:solidFill>
+          </a:ln>
+        </p:spPr>
+        <p:style>
+          <a:lnRef idx="1">
+            <a:schemeClr val="accent1"/>
+          </a:lnRef>
+          <a:fillRef idx="3">
+            <a:schemeClr val="accent1"/>
+          </a:fillRef>
+          <a:effectRef idx="2">
+            <a:schemeClr val="accent1"/>
+          </a:effectRef>
+          <a:fontRef idx="minor">
+            <a:schemeClr val="lt1"/>
+          </a:fontRef>
+        </p:style>
+        <p:txBody>
+          <a:bodyPr rtlCol="0" anchor="ctr"/>
+          <a:lstStyle/>
+          <a:p>
+            <a:pPr algn="ctr"/>
+          </a:p>
+        </p:txBody>
+      </p:sp>
+      <p:sp>
+        <p:nvSpPr>
+          <p:cNvPr id="26" name="TextBox 25"/>
+          <p:cNvSpPr txBox="1"/>
+          <p:nvPr/>
+        </p:nvSpPr>
+        <p:spPr>
+          <a:xfrm>
+            <a:off x="6400800" y="1051560"/>
+            <a:ext cx="5394960" cy="329184"/>
+          </a:xfrm>
+          <a:prstGeom prst="rect">
+            <a:avLst/>
+          </a:prstGeom>
+          <a:noFill/>
+        </p:spPr>
+        <p:txBody>
+          <a:bodyPr wrap="square" lIns="45720" rIns="45720">
+            <a:spAutoFit/>
+          </a:bodyPr>
+          <a:lstStyle/>
+          <a:p>
+            <a:pPr algn="l"/>
+            <a:r>
+              <a:rPr sz="1200" b="1">
+                <a:solidFill>
+                  <a:srgbClr val="27AE60"/>
+                </a:solidFill>
+              </a:rPr>
+              <a:t>TAO (Kim 2025, ICML)</a:t>
+            </a:r>
+          </a:p>
+        </p:txBody>
+      </p:sp>
+      <p:sp>
+        <p:nvSpPr>
+          <p:cNvPr id="27" name="TextBox 26"/>
+          <p:cNvSpPr txBox="1"/>
+          <p:nvPr/>
+        </p:nvSpPr>
+        <p:spPr>
+          <a:xfrm>
+            <a:off x="6400800" y="1353312"/>
+            <a:ext cx="5394960" cy="320040"/>
+          </a:xfrm>
+          <a:prstGeom prst="rect">
+            <a:avLst/>
+          </a:prstGeom>
+          <a:noFill/>
+        </p:spPr>
+        <p:txBody>
+          <a:bodyPr wrap="square" lIns="45720" rIns="45720">
+            <a:spAutoFit/>
+          </a:bodyPr>
+          <a:lstStyle/>
+          <a:p>
+            <a:pPr algn="l"/>
+            <a:r>
+              <a:rPr sz="900" b="0">
+                <a:solidFill>
+                  <a:srgbClr val="34495E"/>
+                </a:solidFill>
+              </a:rPr>
+              <a:t>Tiered Agentic Oversight for healthcare safety.</a:t>
+            </a:r>
+          </a:p>
+        </p:txBody>
+      </p:sp>
+      <p:sp>
+        <p:nvSpPr>
+          <p:cNvPr id="28" name="TextBox 27"/>
+          <p:cNvSpPr txBox="1"/>
+          <p:nvPr/>
+        </p:nvSpPr>
+        <p:spPr>
+          <a:xfrm>
+            <a:off x="6400800" y="1645920"/>
+            <a:ext cx="5394960" cy="320040"/>
+          </a:xfrm>
+          <a:prstGeom prst="rect">
+            <a:avLst/>
+          </a:prstGeom>
+          <a:noFill/>
+        </p:spPr>
+        <p:txBody>
+          <a:bodyPr wrap="square" lIns="45720" rIns="45720">
+            <a:spAutoFit/>
+          </a:bodyPr>
+          <a:lstStyle/>
+          <a:p>
+            <a:pPr algn="l"/>
+            <a:r>
+              <a:rPr sz="900" b="1">
+                <a:solidFill>
+                  <a:srgbClr val="34495E"/>
+                </a:solidFill>
+              </a:rPr>
+              <a:t>Result: +8.2% on 4/5 safety benchmarks · triage 40% → 60% w/ MDs.</a:t>
+            </a:r>
+          </a:p>
+        </p:txBody>
+      </p:sp>
+      <p:sp>
+        <p:nvSpPr>
+          <p:cNvPr id="29" name="TextBox 28"/>
+          <p:cNvSpPr txBox="1"/>
+          <p:nvPr/>
+        </p:nvSpPr>
+        <p:spPr>
+          <a:xfrm>
+            <a:off x="6400800" y="1920240"/>
+            <a:ext cx="5394960" cy="320040"/>
+          </a:xfrm>
+          <a:prstGeom prst="rect">
+            <a:avLst/>
+          </a:prstGeom>
+          <a:noFill/>
+        </p:spPr>
+        <p:txBody>
+          <a:bodyPr wrap="square" lIns="45720" rIns="45720">
+            <a:spAutoFit/>
+          </a:bodyPr>
+          <a:lstStyle/>
+          <a:p>
+            <a:pPr algn="l"/>
+            <a:r>
+              <a:rPr sz="900" b="0">
+                <a:solidFill>
+                  <a:srgbClr val="C0392B"/>
+                </a:solidFill>
+              </a:rPr>
+              <a:t>Missing: Safety wrapper, not a diagnostic pipeline · no case-based memory.</a:t>
+            </a:r>
+          </a:p>
+        </p:txBody>
+      </p:sp>
+      <p:sp>
+        <p:nvSpPr>
+          <p:cNvPr id="30" name="Rounded Rectangle 29"/>
+          <p:cNvSpPr/>
+          <p:nvPr/>
+        </p:nvSpPr>
+        <p:spPr>
+          <a:xfrm>
+            <a:off x="6263640" y="2286000"/>
+            <a:ext cx="5623560" cy="1188719"/>
+          </a:xfrm>
+          <a:prstGeom prst="roundRect">
+            <a:avLst/>
+          </a:prstGeom>
+          <a:solidFill>
+            <a:srgbClr val="FFFFFF"/>
+          </a:solidFill>
+          <a:ln w="15875">
+            <a:solidFill>
+              <a:srgbClr val="1F4E79"/>
+            </a:solidFill>
+          </a:ln>
+        </p:spPr>
+        <p:style>
+          <a:lnRef idx="1">
+            <a:schemeClr val="accent1"/>
+          </a:lnRef>
+          <a:fillRef idx="3">
+            <a:schemeClr val="accent1"/>
+          </a:fillRef>
+          <a:effectRef idx="2">
+            <a:schemeClr val="accent1"/>
+          </a:effectRef>
+          <a:fontRef idx="minor">
+            <a:schemeClr val="lt1"/>
+          </a:fontRef>
+        </p:style>
+        <p:txBody>
+          <a:bodyPr rtlCol="0" anchor="ctr"/>
+          <a:lstStyle/>
+          <a:p>
+            <a:pPr algn="ctr"/>
+          </a:p>
+        </p:txBody>
+      </p:sp>
+      <p:sp>
+        <p:nvSpPr>
+          <p:cNvPr id="31" name="TextBox 30"/>
+          <p:cNvSpPr txBox="1"/>
+          <p:nvPr/>
+        </p:nvSpPr>
+        <p:spPr>
+          <a:xfrm>
+            <a:off x="6400800" y="2331720"/>
+            <a:ext cx="5394960" cy="329184"/>
+          </a:xfrm>
+          <a:prstGeom prst="rect">
+            <a:avLst/>
+          </a:prstGeom>
+          <a:noFill/>
+        </p:spPr>
+        <p:txBody>
+          <a:bodyPr wrap="square" lIns="45720" rIns="45720">
+            <a:spAutoFit/>
+          </a:bodyPr>
+          <a:lstStyle/>
+          <a:p>
+            <a:pPr algn="l"/>
+            <a:r>
+              <a:rPr sz="1200" b="1">
+                <a:solidFill>
+                  <a:srgbClr val="1F4E79"/>
+                </a:solidFill>
+              </a:rPr>
+              <a:t>ClinicalLab (Yan 2024)</a:t>
+            </a:r>
+          </a:p>
+        </p:txBody>
+      </p:sp>
+      <p:sp>
+        <p:nvSpPr>
+          <p:cNvPr id="32" name="TextBox 31"/>
+          <p:cNvSpPr txBox="1"/>
+          <p:nvPr/>
+        </p:nvSpPr>
+        <p:spPr>
+          <a:xfrm>
+            <a:off x="6400800" y="2633472"/>
+            <a:ext cx="5394960" cy="320040"/>
+          </a:xfrm>
+          <a:prstGeom prst="rect">
+            <a:avLst/>
+          </a:prstGeom>
+          <a:noFill/>
+        </p:spPr>
+        <p:txBody>
+          <a:bodyPr wrap="square" lIns="45720" rIns="45720">
+            <a:spAutoFit/>
+          </a:bodyPr>
+          <a:lstStyle/>
+          <a:p>
+            <a:pPr algn="l"/>
+            <a:r>
+              <a:rPr sz="900" b="0">
+                <a:solidFill>
+                  <a:srgbClr val="34495E"/>
+                </a:solidFill>
+              </a:rPr>
+              <a:t>Coordinator + Chief Physician across 11 departments.</a:t>
+            </a:r>
+          </a:p>
+        </p:txBody>
+      </p:sp>
+      <p:sp>
+        <p:nvSpPr>
+          <p:cNvPr id="33" name="TextBox 32"/>
+          <p:cNvSpPr txBox="1"/>
+          <p:nvPr/>
+        </p:nvSpPr>
+        <p:spPr>
+          <a:xfrm>
+            <a:off x="6400800" y="2926080"/>
+            <a:ext cx="5394960" cy="320040"/>
+          </a:xfrm>
+          <a:prstGeom prst="rect">
+            <a:avLst/>
+          </a:prstGeom>
+          <a:noFill/>
+        </p:spPr>
+        <p:txBody>
+          <a:bodyPr wrap="square" lIns="45720" rIns="45720">
+            <a:spAutoFit/>
+          </a:bodyPr>
+          <a:lstStyle/>
+          <a:p>
+            <a:pPr algn="l"/>
+            <a:r>
+              <a:rPr sz="900" b="1">
+                <a:solidFill>
+                  <a:srgbClr val="34495E"/>
+                </a:solidFill>
+              </a:rPr>
+              <a:t>Result: Within ~5% of senior physicians on 1,500 real cases.</a:t>
+            </a:r>
+          </a:p>
+        </p:txBody>
+      </p:sp>
+      <p:sp>
+        <p:nvSpPr>
+          <p:cNvPr id="34" name="TextBox 33"/>
+          <p:cNvSpPr txBox="1"/>
+          <p:nvPr/>
+        </p:nvSpPr>
+        <p:spPr>
+          <a:xfrm>
+            <a:off x="6400800" y="3200400"/>
+            <a:ext cx="5394960" cy="320040"/>
+          </a:xfrm>
+          <a:prstGeom prst="rect">
+            <a:avLst/>
+          </a:prstGeom>
+          <a:noFill/>
+        </p:spPr>
+        <p:txBody>
+          <a:bodyPr wrap="square" lIns="45720" rIns="45720">
+            <a:spAutoFit/>
+          </a:bodyPr>
+          <a:lstStyle/>
+          <a:p>
+            <a:pPr algn="l"/>
+            <a:r>
+              <a:rPr sz="900" b="0">
+                <a:solidFill>
+                  <a:srgbClr val="C0392B"/>
+                </a:solidFill>
+              </a:rPr>
+              <a:t>Missing: Closed-source · no published memory subsystem · no doctor UI.</a:t>
+            </a:r>
+          </a:p>
+        </p:txBody>
+      </p:sp>
+      <p:sp>
+        <p:nvSpPr>
+          <p:cNvPr id="35" name="Rounded Rectangle 34"/>
+          <p:cNvSpPr/>
+          <p:nvPr/>
+        </p:nvSpPr>
+        <p:spPr>
+          <a:xfrm>
+            <a:off x="6263640" y="3566160"/>
+            <a:ext cx="5623560" cy="1188719"/>
+          </a:xfrm>
+          <a:prstGeom prst="roundRect">
+            <a:avLst/>
+          </a:prstGeom>
+          <a:solidFill>
+            <a:srgbClr val="FFFFFF"/>
+          </a:solidFill>
+          <a:ln w="15875">
+            <a:solidFill>
+              <a:srgbClr val="16A085"/>
+            </a:solidFill>
+          </a:ln>
+        </p:spPr>
+        <p:style>
+          <a:lnRef idx="1">
+            <a:schemeClr val="accent1"/>
+          </a:lnRef>
+          <a:fillRef idx="3">
+            <a:schemeClr val="accent1"/>
+          </a:fillRef>
+          <a:effectRef idx="2">
+            <a:schemeClr val="accent1"/>
+          </a:effectRef>
+          <a:fontRef idx="minor">
+            <a:schemeClr val="lt1"/>
+          </a:fontRef>
+        </p:style>
+        <p:txBody>
+          <a:bodyPr rtlCol="0" anchor="ctr"/>
+          <a:lstStyle/>
+          <a:p>
+            <a:pPr algn="ctr"/>
+          </a:p>
+        </p:txBody>
+      </p:sp>
+      <p:sp>
+        <p:nvSpPr>
+          <p:cNvPr id="36" name="TextBox 35"/>
+          <p:cNvSpPr txBox="1"/>
+          <p:nvPr/>
+        </p:nvSpPr>
+        <p:spPr>
+          <a:xfrm>
+            <a:off x="6400800" y="3611879"/>
+            <a:ext cx="5394960" cy="329184"/>
+          </a:xfrm>
+          <a:prstGeom prst="rect">
+            <a:avLst/>
+          </a:prstGeom>
+          <a:noFill/>
+        </p:spPr>
+        <p:txBody>
+          <a:bodyPr wrap="square" lIns="45720" rIns="45720">
+            <a:spAutoFit/>
+          </a:bodyPr>
+          <a:lstStyle/>
+          <a:p>
+            <a:pPr algn="l"/>
+            <a:r>
+              <a:rPr sz="1200" b="1">
+                <a:solidFill>
+                  <a:srgbClr val="16A085"/>
+                </a:solidFill>
+              </a:rPr>
+              <a:t>ZODIAC (Zhou 2024)</a:t>
+            </a:r>
+          </a:p>
+        </p:txBody>
+      </p:sp>
+      <p:sp>
+        <p:nvSpPr>
+          <p:cNvPr id="37" name="TextBox 36"/>
+          <p:cNvSpPr txBox="1"/>
+          <p:nvPr/>
+        </p:nvSpPr>
+        <p:spPr>
+          <a:xfrm>
+            <a:off x="6400800" y="3913632"/>
+            <a:ext cx="5394960" cy="320040"/>
+          </a:xfrm>
+          <a:prstGeom prst="rect">
+            <a:avLst/>
+          </a:prstGeom>
+          <a:noFill/>
+        </p:spPr>
+        <p:txBody>
+          <a:bodyPr wrap="square" lIns="45720" rIns="45720">
+            <a:spAutoFit/>
+          </a:bodyPr>
+          <a:lstStyle/>
+          <a:p>
+            <a:pPr algn="l"/>
+            <a:r>
+              <a:rPr sz="900" b="0">
+                <a:solidFill>
+                  <a:srgbClr val="34495E"/>
+                </a:solidFill>
+              </a:rPr>
+              <a:t>5-agent cardiology + clinician review.</a:t>
+            </a:r>
+          </a:p>
+        </p:txBody>
+      </p:sp>
+      <p:sp>
+        <p:nvSpPr>
+          <p:cNvPr id="38" name="TextBox 37"/>
+          <p:cNvSpPr txBox="1"/>
+          <p:nvPr/>
+        </p:nvSpPr>
+        <p:spPr>
+          <a:xfrm>
+            <a:off x="6400800" y="4206240"/>
+            <a:ext cx="5394960" cy="320040"/>
+          </a:xfrm>
+          <a:prstGeom prst="rect">
+            <a:avLst/>
+          </a:prstGeom>
+          <a:noFill/>
+        </p:spPr>
+        <p:txBody>
+          <a:bodyPr wrap="square" lIns="45720" rIns="45720">
+            <a:spAutoFit/>
+          </a:bodyPr>
+          <a:lstStyle/>
+          <a:p>
+            <a:pPr algn="l"/>
+            <a:r>
+              <a:rPr sz="900" b="1">
+                <a:solidFill>
+                  <a:srgbClr val="34495E"/>
+                </a:solidFill>
+              </a:rPr>
+              <a:t>Result: Cardiologist-level on 7/8 metrics (qualitative).</a:t>
+            </a:r>
+          </a:p>
+        </p:txBody>
+      </p:sp>
+      <p:sp>
+        <p:nvSpPr>
+          <p:cNvPr id="39" name="TextBox 38"/>
+          <p:cNvSpPr txBox="1"/>
+          <p:nvPr/>
+        </p:nvSpPr>
+        <p:spPr>
+          <a:xfrm>
+            <a:off x="6400800" y="4480560"/>
+            <a:ext cx="5394960" cy="320040"/>
+          </a:xfrm>
+          <a:prstGeom prst="rect">
+            <a:avLst/>
+          </a:prstGeom>
+          <a:noFill/>
+        </p:spPr>
+        <p:txBody>
+          <a:bodyPr wrap="square" lIns="45720" rIns="45720">
+            <a:spAutoFit/>
+          </a:bodyPr>
+          <a:lstStyle/>
+          <a:p>
+            <a:pPr algn="l"/>
+            <a:r>
+              <a:rPr sz="900" b="0">
+                <a:solidFill>
+                  <a:srgbClr val="C0392B"/>
+                </a:solidFill>
+              </a:rPr>
+              <a:t>Missing: Single specialty · no memory · no treatment plan · no open backbone.</a:t>
+            </a:r>
+          </a:p>
+        </p:txBody>
+      </p:sp>
+      <p:sp>
+        <p:nvSpPr>
+          <p:cNvPr id="40" name="TextBox 39"/>
+          <p:cNvSpPr txBox="1"/>
+          <p:nvPr/>
+        </p:nvSpPr>
+        <p:spPr>
+          <a:xfrm>
+            <a:off x="320040" y="6263640"/>
+            <a:ext cx="11521440" cy="365760"/>
+          </a:xfrm>
+          <a:prstGeom prst="rect">
+            <a:avLst/>
+          </a:prstGeom>
+          <a:noFill/>
+        </p:spPr>
+        <p:txBody>
+          <a:bodyPr wrap="square" lIns="45720" rIns="45720">
+            <a:spAutoFit/>
+          </a:bodyPr>
+          <a:lstStyle/>
+          <a:p>
+            <a:pPr algn="ctr"/>
+            <a:r>
+              <a:rPr sz="1000" b="0">
+                <a:solidFill>
+                  <a:srgbClr val="7F8C8D"/>
+                </a:solidFill>
+              </a:rPr>
+              <a:t>Comparison is on multiple axes: cohort + headline + what each system leaves out. CMADS fills the union of those gaps.</a:t>
+            </a:r>
+          </a:p>
+        </p:txBody>
+      </p:sp>
+    </p:spTree>
+  </p:cSld>
+  <p:clrMapOvr>
+    <a:masterClrMapping/>
+  </p:clrMapOvr>
+</p:sld>
+</file>
+
+<file path=ppt/slides/slide7.xml><?xml version="1.0" encoding="utf-8"?>
 <p:sld xmlns:a="http://schemas.openxmlformats.org/drawingml/2006/main" xmlns:p="http://schemas.openxmlformats.org/presentationml/2006/main" xmlns:r="http://schemas.openxmlformats.org/officeDocument/2006/relationships">
   <p:cSld>
     <p:spTree>

</xml_diff>